<commit_message>
docs: mise a jour des trois documents en v1.1 (Aout 2026)
Guide utilisateur : connexion par email ou telephone, chapitre 12
(multi-tontine, tontine courante) et chapitre 13 (assistant de reprise,
tontine a lot, import Excel des membres, rapports, sanctions configurables).

Presentation PDF et PPTX : grille passee de 9 a 12 fonctionnalites (aides
sur bareme, reprise en cours, rapports PDF, tontine a lot), section
multi-tontine reecrite (elle decrivait encore un compte par tontine) et
nouvelle diapositive dediee aux aides sur bareme.

nginx : les PDF/PPTX ont des URLs sans hash mais etaient caches 7 jours,
si bien qu'une nouvelle version publiee restait invisible cote navigateur.
Passage en no-cache + must-revalidate (revalidation par ETag).

generate-pdf.py : le nom de sortie de la presentation est aligne sur le
fichier reellement servi par l'application.

Correction du nom de l'auteur : Leutche -> Leutcho.
</commit_message>
<xml_diff>
--- a/tontinepro-frontend/public/docs/TontinePro-Presentation.pptx
+++ b/tontinepro-frontend/public/docs/TontinePro-Presentation.pptx
@@ -12,9 +12,10 @@
     <p:sldId id="260" r:id="rId6"/>
     <p:sldId id="261" r:id="rId7"/>
     <p:sldId id="262" r:id="rId8"/>
+    <p:sldId id="263" r:id="rId9"/>
   </p:sldIdLst>
   <p:notesMasterIdLst>
-    <p:notesMasterId r:id="rId9"/>
+    <p:notesMasterId r:id="rId10"/>
   </p:notesMasterIdLst>
   <p:sldSz cx="12192000" cy="6858000"/>
   <p:notesSz cx="6858000" cy="12192000"/>
@@ -1060,6 +1061,94 @@
             <a:fld id="{F7021451-1387-4CA6-816F-3879F97B5CBC}" type="slidenum">
               <a:rPr lang="en-US"/>
               <a:t>7</a:t>
+            </a:fld>
+            <a:endParaRPr lang="en-US"/>
+          </a:p>
+        </p:txBody>
+      </p:sp>
+    </p:spTree>
+    <p:extLst>
+      <p:ext uri="{BB962C8B-B14F-4D97-AF65-F5344CB8AC3E}">
+        <p14:creationId xmlns:p14="http://schemas.microsoft.com/office/powerpoint/2010/main" val="1024086991"/>
+      </p:ext>
+    </p:extLst>
+  </p:cSld>
+  <p:clrMapOvr>
+    <a:masterClrMapping/>
+  </p:clrMapOvr>
+</p:notes>
+</file>
+
+<file path=ppt/notesSlides/notesSlide8.xml><?xml version="1.0" encoding="utf-8"?>
+<p:notes xmlns:a="http://schemas.openxmlformats.org/drawingml/2006/main" xmlns:r="http://schemas.openxmlformats.org/officeDocument/2006/relationships" xmlns:p="http://schemas.openxmlformats.org/presentationml/2006/main">
+  <p:cSld>
+    <p:spTree>
+      <p:nvGrpSpPr>
+        <p:cNvPr id="1" name=""/>
+        <p:cNvGrpSpPr/>
+        <p:nvPr/>
+      </p:nvGrpSpPr>
+      <p:grpSpPr>
+        <a:xfrm>
+          <a:off x="0" y="0"/>
+          <a:ext cx="0" cy="0"/>
+          <a:chOff x="0" y="0"/>
+          <a:chExt cx="0" cy="0"/>
+        </a:xfrm>
+      </p:grpSpPr>
+      <p:sp>
+        <p:nvSpPr>
+          <p:cNvPr id="2" name="Slide Image Placeholder 1"/>
+          <p:cNvSpPr>
+            <a:spLocks noGrp="1" noRot="1" noChangeAspect="1"/>
+          </p:cNvSpPr>
+          <p:nvPr>
+            <p:ph type="sldImg"/>
+          </p:nvPr>
+        </p:nvSpPr>
+        <p:spPr/>
+      </p:sp>
+      <p:sp>
+        <p:nvSpPr>
+          <p:cNvPr id="3" name="Notes Placeholder 2"/>
+          <p:cNvSpPr>
+            <a:spLocks noGrp="1"/>
+          </p:cNvSpPr>
+          <p:nvPr>
+            <p:ph type="body" idx="1"/>
+          </p:nvPr>
+        </p:nvSpPr>
+        <p:spPr/>
+        <p:txBody>
+          <a:bodyPr/>
+          <a:lstStyle/>
+          <a:p>
+            <a:r>
+              <a:rPr lang="en-US" dirty="0"/>
+              <a:t/>
+            </a:r>
+            <a:endParaRPr lang="en-US" dirty="0"/>
+          </a:p>
+        </p:txBody>
+      </p:sp>
+      <p:sp>
+        <p:nvSpPr>
+          <p:cNvPr id="4" name="Slide Number Placeholder 3"/>
+          <p:cNvSpPr>
+            <a:spLocks noGrp="1"/>
+          </p:cNvSpPr>
+          <p:nvPr>
+            <p:ph type="sldNum" sz="quarter" idx="10"/>
+          </p:nvPr>
+        </p:nvSpPr>
+        <p:spPr/>
+        <p:txBody>
+          <a:bodyPr/>
+          <a:lstStyle/>
+          <a:p>
+            <a:fld id="{F7021451-1387-4CA6-816F-3879F97B5CBC}" type="slidenum">
+              <a:rPr lang="en-US"/>
+              <a:t>8</a:t>
             </a:fld>
             <a:endParaRPr lang="en-US"/>
           </a:p>
@@ -1586,7 +1675,7 @@
                   <a:srgbClr val="818CF8"/>
                 </a:solidFill>
               </a:rPr>
-              <a:t>Version 1.0  ·  Mai 2026  ·  JumpyTech</a:t>
+              <a:t>Version 1.1  ·  Août 2026  ·  JumpyTech</a:t>
             </a:r>
             <a:endParaRPr lang="en-US" sz="1300" dirty="0"/>
           </a:p>
@@ -2316,7 +2405,7 @@
                   <a:srgbClr val="94A3B8"/>
                 </a:solidFill>
               </a:rPr>
-              <a:t>TontinePro v1.0  ·  JumpyTech  ·  © 2026</a:t>
+              <a:t>TontinePro v1.1  ·  JumpyTech  ·  © 2026</a:t>
             </a:r>
             <a:endParaRPr lang="en-US" sz="800" dirty="0"/>
           </a:p>
@@ -2471,7 +2560,7 @@
         <p:spPr>
           <a:xfrm>
             <a:off x="274320" y="1188720"/>
-            <a:ext cx="3657600" cy="1463040"/>
+            <a:ext cx="2743200" cy="1463040"/>
           </a:xfrm>
           <a:prstGeom prst="roundRect">
             <a:avLst/>
@@ -2495,31 +2584,31 @@
         </p:nvSpPr>
         <p:spPr>
           <a:xfrm>
-            <a:off x="411480" y="1325880"/>
-            <a:ext cx="640080" cy="640080"/>
-          </a:xfrm>
-          <a:prstGeom prst="rect">
-            <a:avLst/>
-          </a:prstGeom>
-          <a:noFill/>
-          <a:ln/>
-        </p:spPr>
-        <p:txBody>
-          <a:bodyPr wrap="square" rtlCol="0" anchor="ctr"/>
-          <a:lstStyle/>
-          <a:p>
-            <a:pPr indent="0" marL="0">
-              <a:buNone/>
-            </a:pPr>
-            <a:r>
-              <a:rPr lang="en-US" sz="2200" dirty="0">
+            <a:off x="411480" y="1298448"/>
+            <a:ext cx="457200" cy="411480"/>
+          </a:xfrm>
+          <a:prstGeom prst="rect">
+            <a:avLst/>
+          </a:prstGeom>
+          <a:noFill/>
+          <a:ln/>
+        </p:spPr>
+        <p:txBody>
+          <a:bodyPr wrap="square" rtlCol="0" anchor="ctr"/>
+          <a:lstStyle/>
+          <a:p>
+            <a:pPr indent="0" marL="0">
+              <a:buNone/>
+            </a:pPr>
+            <a:r>
+              <a:rPr lang="en-US" sz="1800" dirty="0">
                 <a:solidFill>
                   <a:srgbClr val="000000"/>
                 </a:solidFill>
               </a:rPr>
               <a:t>💳</a:t>
             </a:r>
-            <a:endParaRPr lang="en-US" sz="2200" dirty="0"/>
+            <a:endParaRPr lang="en-US" sz="1800" dirty="0"/>
           </a:p>
         </p:txBody>
       </p:sp>
@@ -2531,31 +2620,31 @@
         </p:nvSpPr>
         <p:spPr>
           <a:xfrm>
-            <a:off x="1097280" y="1325880"/>
-            <a:ext cx="2651760" cy="365760"/>
-          </a:xfrm>
-          <a:prstGeom prst="rect">
-            <a:avLst/>
-          </a:prstGeom>
-          <a:noFill/>
-          <a:ln/>
-        </p:spPr>
-        <p:txBody>
-          <a:bodyPr wrap="square" rtlCol="0" anchor="ctr"/>
-          <a:lstStyle/>
-          <a:p>
-            <a:pPr indent="0" marL="0">
-              <a:buNone/>
-            </a:pPr>
-            <a:r>
-              <a:rPr lang="en-US" sz="1200" b="1" dirty="0">
+            <a:off x="914400" y="1298448"/>
+            <a:ext cx="2011680" cy="411480"/>
+          </a:xfrm>
+          <a:prstGeom prst="rect">
+            <a:avLst/>
+          </a:prstGeom>
+          <a:noFill/>
+          <a:ln/>
+        </p:spPr>
+        <p:txBody>
+          <a:bodyPr wrap="square" rtlCol="0" anchor="ctr"/>
+          <a:lstStyle/>
+          <a:p>
+            <a:pPr indent="0" marL="0">
+              <a:buNone/>
+            </a:pPr>
+            <a:r>
+              <a:rPr lang="en-US" sz="1100" b="1" dirty="0">
                 <a:solidFill>
                   <a:srgbClr val="1E293B"/>
                 </a:solidFill>
               </a:rPr>
               <a:t>Cotisations</a:t>
             </a:r>
-            <a:endParaRPr lang="en-US" sz="1200" dirty="0"/>
+            <a:endParaRPr lang="en-US" sz="1100" dirty="0"/>
           </a:p>
         </p:txBody>
       </p:sp>
@@ -2567,31 +2656,31 @@
         </p:nvSpPr>
         <p:spPr>
           <a:xfrm>
-            <a:off x="1097280" y="1691640"/>
-            <a:ext cx="2651760" cy="731520"/>
-          </a:xfrm>
-          <a:prstGeom prst="rect">
-            <a:avLst/>
-          </a:prstGeom>
-          <a:noFill/>
-          <a:ln/>
-        </p:spPr>
-        <p:txBody>
-          <a:bodyPr wrap="square" rtlCol="0" anchor="ctr"/>
-          <a:lstStyle/>
-          <a:p>
-            <a:pPr indent="0" marL="0">
-              <a:buNone/>
-            </a:pPr>
-            <a:r>
-              <a:rPr lang="en-US" sz="950" dirty="0">
+            <a:off x="411480" y="1755648"/>
+            <a:ext cx="2468880" cy="777240"/>
+          </a:xfrm>
+          <a:prstGeom prst="rect">
+            <a:avLst/>
+          </a:prstGeom>
+          <a:noFill/>
+          <a:ln/>
+        </p:spPr>
+        <p:txBody>
+          <a:bodyPr wrap="square" rtlCol="0" anchor="ctr"/>
+          <a:lstStyle/>
+          <a:p>
+            <a:pPr indent="0" marL="0">
+              <a:buNone/>
+            </a:pPr>
+            <a:r>
+              <a:rPr lang="en-US" sz="900" dirty="0">
                 <a:solidFill>
                   <a:srgbClr val="64748B"/>
                 </a:solidFill>
               </a:rPr>
               <a:t>Génération auto, saisie de séance, statut en temps réel</a:t>
             </a:r>
-            <a:endParaRPr lang="en-US" sz="950" dirty="0"/>
+            <a:endParaRPr lang="en-US" sz="900" dirty="0"/>
           </a:p>
         </p:txBody>
       </p:sp>
@@ -2603,8 +2692,8 @@
         </p:nvSpPr>
         <p:spPr>
           <a:xfrm>
-            <a:off x="4206240" y="1188720"/>
-            <a:ext cx="3657600" cy="1463040"/>
+            <a:off x="3246120" y="1188720"/>
+            <a:ext cx="2743200" cy="1463040"/>
           </a:xfrm>
           <a:prstGeom prst="roundRect">
             <a:avLst/>
@@ -2628,31 +2717,31 @@
         </p:nvSpPr>
         <p:spPr>
           <a:xfrm>
-            <a:off x="4343400" y="1325880"/>
-            <a:ext cx="640080" cy="640080"/>
-          </a:xfrm>
-          <a:prstGeom prst="rect">
-            <a:avLst/>
-          </a:prstGeom>
-          <a:noFill/>
-          <a:ln/>
-        </p:spPr>
-        <p:txBody>
-          <a:bodyPr wrap="square" rtlCol="0" anchor="ctr"/>
-          <a:lstStyle/>
-          <a:p>
-            <a:pPr indent="0" marL="0">
-              <a:buNone/>
-            </a:pPr>
-            <a:r>
-              <a:rPr lang="en-US" sz="2200" dirty="0">
+            <a:off x="3383280" y="1298448"/>
+            <a:ext cx="457200" cy="411480"/>
+          </a:xfrm>
+          <a:prstGeom prst="rect">
+            <a:avLst/>
+          </a:prstGeom>
+          <a:noFill/>
+          <a:ln/>
+        </p:spPr>
+        <p:txBody>
+          <a:bodyPr wrap="square" rtlCol="0" anchor="ctr"/>
+          <a:lstStyle/>
+          <a:p>
+            <a:pPr indent="0" marL="0">
+              <a:buNone/>
+            </a:pPr>
+            <a:r>
+              <a:rPr lang="en-US" sz="1800" dirty="0">
                 <a:solidFill>
                   <a:srgbClr val="000000"/>
                 </a:solidFill>
               </a:rPr>
               <a:t>🔄</a:t>
             </a:r>
-            <a:endParaRPr lang="en-US" sz="2200" dirty="0"/>
+            <a:endParaRPr lang="en-US" sz="1800" dirty="0"/>
           </a:p>
         </p:txBody>
       </p:sp>
@@ -2664,31 +2753,31 @@
         </p:nvSpPr>
         <p:spPr>
           <a:xfrm>
-            <a:off x="5029200" y="1325880"/>
-            <a:ext cx="2651760" cy="365760"/>
-          </a:xfrm>
-          <a:prstGeom prst="rect">
-            <a:avLst/>
-          </a:prstGeom>
-          <a:noFill/>
-          <a:ln/>
-        </p:spPr>
-        <p:txBody>
-          <a:bodyPr wrap="square" rtlCol="0" anchor="ctr"/>
-          <a:lstStyle/>
-          <a:p>
-            <a:pPr indent="0" marL="0">
-              <a:buNone/>
-            </a:pPr>
-            <a:r>
-              <a:rPr lang="en-US" sz="1200" b="1" dirty="0">
+            <a:off x="3886200" y="1298448"/>
+            <a:ext cx="2011680" cy="411480"/>
+          </a:xfrm>
+          <a:prstGeom prst="rect">
+            <a:avLst/>
+          </a:prstGeom>
+          <a:noFill/>
+          <a:ln/>
+        </p:spPr>
+        <p:txBody>
+          <a:bodyPr wrap="square" rtlCol="0" anchor="ctr"/>
+          <a:lstStyle/>
+          <a:p>
+            <a:pPr indent="0" marL="0">
+              <a:buNone/>
+            </a:pPr>
+            <a:r>
+              <a:rPr lang="en-US" sz="1100" b="1" dirty="0">
                 <a:solidFill>
                   <a:srgbClr val="1E293B"/>
                 </a:solidFill>
               </a:rPr>
               <a:t>Sessions</a:t>
             </a:r>
-            <a:endParaRPr lang="en-US" sz="1200" dirty="0"/>
+            <a:endParaRPr lang="en-US" sz="1100" dirty="0"/>
           </a:p>
         </p:txBody>
       </p:sp>
@@ -2700,31 +2789,31 @@
         </p:nvSpPr>
         <p:spPr>
           <a:xfrm>
-            <a:off x="5029200" y="1691640"/>
-            <a:ext cx="2651760" cy="731520"/>
-          </a:xfrm>
-          <a:prstGeom prst="rect">
-            <a:avLst/>
-          </a:prstGeom>
-          <a:noFill/>
-          <a:ln/>
-        </p:spPr>
-        <p:txBody>
-          <a:bodyPr wrap="square" rtlCol="0" anchor="ctr"/>
-          <a:lstStyle/>
-          <a:p>
-            <a:pPr indent="0" marL="0">
-              <a:buNone/>
-            </a:pPr>
-            <a:r>
-              <a:rPr lang="en-US" sz="950" dirty="0">
+            <a:off x="3383280" y="1755648"/>
+            <a:ext cx="2468880" cy="777240"/>
+          </a:xfrm>
+          <a:prstGeom prst="rect">
+            <a:avLst/>
+          </a:prstGeom>
+          <a:noFill/>
+          <a:ln/>
+        </p:spPr>
+        <p:txBody>
+          <a:bodyPr wrap="square" rtlCol="0" anchor="ctr"/>
+          <a:lstStyle/>
+          <a:p>
+            <a:pPr indent="0" marL="0">
+              <a:buNone/>
+            </a:pPr>
+            <a:r>
+              <a:rPr lang="en-US" sz="900" dirty="0">
                 <a:solidFill>
                   <a:srgbClr val="64748B"/>
                 </a:solidFill>
               </a:rPr>
               <a:t>Tours de bénéfice, calendrier, validation du pot mensuel</a:t>
             </a:r>
-            <a:endParaRPr lang="en-US" sz="950" dirty="0"/>
+            <a:endParaRPr lang="en-US" sz="900" dirty="0"/>
           </a:p>
         </p:txBody>
       </p:sp>
@@ -2736,8 +2825,8 @@
         </p:nvSpPr>
         <p:spPr>
           <a:xfrm>
-            <a:off x="8138160" y="1188720"/>
-            <a:ext cx="3657600" cy="1463040"/>
+            <a:off x="6217920" y="1188720"/>
+            <a:ext cx="2743200" cy="1463040"/>
           </a:xfrm>
           <a:prstGeom prst="roundRect">
             <a:avLst/>
@@ -2761,31 +2850,31 @@
         </p:nvSpPr>
         <p:spPr>
           <a:xfrm>
-            <a:off x="8275320" y="1325880"/>
-            <a:ext cx="640080" cy="640080"/>
-          </a:xfrm>
-          <a:prstGeom prst="rect">
-            <a:avLst/>
-          </a:prstGeom>
-          <a:noFill/>
-          <a:ln/>
-        </p:spPr>
-        <p:txBody>
-          <a:bodyPr wrap="square" rtlCol="0" anchor="ctr"/>
-          <a:lstStyle/>
-          <a:p>
-            <a:pPr indent="0" marL="0">
-              <a:buNone/>
-            </a:pPr>
-            <a:r>
-              <a:rPr lang="en-US" sz="2200" dirty="0">
+            <a:off x="6355080" y="1298448"/>
+            <a:ext cx="457200" cy="411480"/>
+          </a:xfrm>
+          <a:prstGeom prst="rect">
+            <a:avLst/>
+          </a:prstGeom>
+          <a:noFill/>
+          <a:ln/>
+        </p:spPr>
+        <p:txBody>
+          <a:bodyPr wrap="square" rtlCol="0" anchor="ctr"/>
+          <a:lstStyle/>
+          <a:p>
+            <a:pPr indent="0" marL="0">
+              <a:buNone/>
+            </a:pPr>
+            <a:r>
+              <a:rPr lang="en-US" sz="1800" dirty="0">
                 <a:solidFill>
                   <a:srgbClr val="000000"/>
                 </a:solidFill>
               </a:rPr>
               <a:t>🏦</a:t>
             </a:r>
-            <a:endParaRPr lang="en-US" sz="2200" dirty="0"/>
+            <a:endParaRPr lang="en-US" sz="1800" dirty="0"/>
           </a:p>
         </p:txBody>
       </p:sp>
@@ -2797,31 +2886,31 @@
         </p:nvSpPr>
         <p:spPr>
           <a:xfrm>
-            <a:off x="8961120" y="1325880"/>
-            <a:ext cx="2651760" cy="365760"/>
-          </a:xfrm>
-          <a:prstGeom prst="rect">
-            <a:avLst/>
-          </a:prstGeom>
-          <a:noFill/>
-          <a:ln/>
-        </p:spPr>
-        <p:txBody>
-          <a:bodyPr wrap="square" rtlCol="0" anchor="ctr"/>
-          <a:lstStyle/>
-          <a:p>
-            <a:pPr indent="0" marL="0">
-              <a:buNone/>
-            </a:pPr>
-            <a:r>
-              <a:rPr lang="en-US" sz="1200" b="1" dirty="0">
+            <a:off x="6858000" y="1298448"/>
+            <a:ext cx="2011680" cy="411480"/>
+          </a:xfrm>
+          <a:prstGeom prst="rect">
+            <a:avLst/>
+          </a:prstGeom>
+          <a:noFill/>
+          <a:ln/>
+        </p:spPr>
+        <p:txBody>
+          <a:bodyPr wrap="square" rtlCol="0" anchor="ctr"/>
+          <a:lstStyle/>
+          <a:p>
+            <a:pPr indent="0" marL="0">
+              <a:buNone/>
+            </a:pPr>
+            <a:r>
+              <a:rPr lang="en-US" sz="1100" b="1" dirty="0">
                 <a:solidFill>
                   <a:srgbClr val="1E293B"/>
                 </a:solidFill>
               </a:rPr>
               <a:t>Épargne</a:t>
             </a:r>
-            <a:endParaRPr lang="en-US" sz="1200" dirty="0"/>
+            <a:endParaRPr lang="en-US" sz="1100" dirty="0"/>
           </a:p>
         </p:txBody>
       </p:sp>
@@ -2833,31 +2922,31 @@
         </p:nvSpPr>
         <p:spPr>
           <a:xfrm>
-            <a:off x="8961120" y="1691640"/>
-            <a:ext cx="2651760" cy="731520"/>
-          </a:xfrm>
-          <a:prstGeom prst="rect">
-            <a:avLst/>
-          </a:prstGeom>
-          <a:noFill/>
-          <a:ln/>
-        </p:spPr>
-        <p:txBody>
-          <a:bodyPr wrap="square" rtlCol="0" anchor="ctr"/>
-          <a:lstStyle/>
-          <a:p>
-            <a:pPr indent="0" marL="0">
-              <a:buNone/>
-            </a:pPr>
-            <a:r>
-              <a:rPr lang="en-US" sz="950" dirty="0">
+            <a:off x="6355080" y="1755648"/>
+            <a:ext cx="2468880" cy="777240"/>
+          </a:xfrm>
+          <a:prstGeom prst="rect">
+            <a:avLst/>
+          </a:prstGeom>
+          <a:noFill/>
+          <a:ln/>
+        </p:spPr>
+        <p:txBody>
+          <a:bodyPr wrap="square" rtlCol="0" anchor="ctr"/>
+          <a:lstStyle/>
+          <a:p>
+            <a:pPr indent="0" marL="0">
+              <a:buNone/>
+            </a:pPr>
+            <a:r>
+              <a:rPr lang="en-US" sz="900" dirty="0">
                 <a:solidFill>
                   <a:srgbClr val="64748B"/>
                 </a:solidFill>
               </a:rPr>
               <a:t>Compte individuel, capital prêtable, intérêts distribués</a:t>
             </a:r>
-            <a:endParaRPr lang="en-US" sz="950" dirty="0"/>
+            <a:endParaRPr lang="en-US" sz="900" dirty="0"/>
           </a:p>
         </p:txBody>
       </p:sp>
@@ -2869,8 +2958,8 @@
         </p:nvSpPr>
         <p:spPr>
           <a:xfrm>
-            <a:off x="274320" y="2834640"/>
-            <a:ext cx="3657600" cy="1463040"/>
+            <a:off x="9189720" y="1188720"/>
+            <a:ext cx="2743200" cy="1463040"/>
           </a:xfrm>
           <a:prstGeom prst="roundRect">
             <a:avLst/>
@@ -2894,31 +2983,31 @@
         </p:nvSpPr>
         <p:spPr>
           <a:xfrm>
-            <a:off x="411480" y="2971800"/>
-            <a:ext cx="640080" cy="640080"/>
-          </a:xfrm>
-          <a:prstGeom prst="rect">
-            <a:avLst/>
-          </a:prstGeom>
-          <a:noFill/>
-          <a:ln/>
-        </p:spPr>
-        <p:txBody>
-          <a:bodyPr wrap="square" rtlCol="0" anchor="ctr"/>
-          <a:lstStyle/>
-          <a:p>
-            <a:pPr indent="0" marL="0">
-              <a:buNone/>
-            </a:pPr>
-            <a:r>
-              <a:rPr lang="en-US" sz="2200" dirty="0">
+            <a:off x="9326880" y="1298448"/>
+            <a:ext cx="457200" cy="411480"/>
+          </a:xfrm>
+          <a:prstGeom prst="rect">
+            <a:avLst/>
+          </a:prstGeom>
+          <a:noFill/>
+          <a:ln/>
+        </p:spPr>
+        <p:txBody>
+          <a:bodyPr wrap="square" rtlCol="0" anchor="ctr"/>
+          <a:lstStyle/>
+          <a:p>
+            <a:pPr indent="0" marL="0">
+              <a:buNone/>
+            </a:pPr>
+            <a:r>
+              <a:rPr lang="en-US" sz="1800" dirty="0">
                 <a:solidFill>
                   <a:srgbClr val="000000"/>
                 </a:solidFill>
               </a:rPr>
               <a:t>📋</a:t>
             </a:r>
-            <a:endParaRPr lang="en-US" sz="2200" dirty="0"/>
+            <a:endParaRPr lang="en-US" sz="1800" dirty="0"/>
           </a:p>
         </p:txBody>
       </p:sp>
@@ -2930,31 +3019,31 @@
         </p:nvSpPr>
         <p:spPr>
           <a:xfrm>
-            <a:off x="1097280" y="2971800"/>
-            <a:ext cx="2651760" cy="365760"/>
-          </a:xfrm>
-          <a:prstGeom prst="rect">
-            <a:avLst/>
-          </a:prstGeom>
-          <a:noFill/>
-          <a:ln/>
-        </p:spPr>
-        <p:txBody>
-          <a:bodyPr wrap="square" rtlCol="0" anchor="ctr"/>
-          <a:lstStyle/>
-          <a:p>
-            <a:pPr indent="0" marL="0">
-              <a:buNone/>
-            </a:pPr>
-            <a:r>
-              <a:rPr lang="en-US" sz="1200" b="1" dirty="0">
+            <a:off x="9829800" y="1298448"/>
+            <a:ext cx="2011680" cy="411480"/>
+          </a:xfrm>
+          <a:prstGeom prst="rect">
+            <a:avLst/>
+          </a:prstGeom>
+          <a:noFill/>
+          <a:ln/>
+        </p:spPr>
+        <p:txBody>
+          <a:bodyPr wrap="square" rtlCol="0" anchor="ctr"/>
+          <a:lstStyle/>
+          <a:p>
+            <a:pPr indent="0" marL="0">
+              <a:buNone/>
+            </a:pPr>
+            <a:r>
+              <a:rPr lang="en-US" sz="1100" b="1" dirty="0">
                 <a:solidFill>
                   <a:srgbClr val="1E293B"/>
                 </a:solidFill>
               </a:rPr>
               <a:t>Prêts</a:t>
             </a:r>
-            <a:endParaRPr lang="en-US" sz="1200" dirty="0"/>
+            <a:endParaRPr lang="en-US" sz="1100" dirty="0"/>
           </a:p>
         </p:txBody>
       </p:sp>
@@ -2966,31 +3055,31 @@
         </p:nvSpPr>
         <p:spPr>
           <a:xfrm>
-            <a:off x="1097280" y="3337560"/>
-            <a:ext cx="2651760" cy="731520"/>
-          </a:xfrm>
-          <a:prstGeom prst="rect">
-            <a:avLst/>
-          </a:prstGeom>
-          <a:noFill/>
-          <a:ln/>
-        </p:spPr>
-        <p:txBody>
-          <a:bodyPr wrap="square" rtlCol="0" anchor="ctr"/>
-          <a:lstStyle/>
-          <a:p>
-            <a:pPr indent="0" marL="0">
-              <a:buNone/>
-            </a:pPr>
-            <a:r>
-              <a:rPr lang="en-US" sz="950" dirty="0">
+            <a:off x="9326880" y="1755648"/>
+            <a:ext cx="2468880" cy="777240"/>
+          </a:xfrm>
+          <a:prstGeom prst="rect">
+            <a:avLst/>
+          </a:prstGeom>
+          <a:noFill/>
+          <a:ln/>
+        </p:spPr>
+        <p:txBody>
+          <a:bodyPr wrap="square" rtlCol="0" anchor="ctr"/>
+          <a:lstStyle/>
+          <a:p>
+            <a:pPr indent="0" marL="0">
+              <a:buNone/>
+            </a:pPr>
+            <a:r>
+              <a:rPr lang="en-US" sz="900" dirty="0">
                 <a:solidFill>
                   <a:srgbClr val="64748B"/>
                 </a:solidFill>
               </a:rPr>
               <a:t>Demande + documents, validation, échéancier automatique</a:t>
             </a:r>
-            <a:endParaRPr lang="en-US" sz="950" dirty="0"/>
+            <a:endParaRPr lang="en-US" sz="900" dirty="0"/>
           </a:p>
         </p:txBody>
       </p:sp>
@@ -3002,8 +3091,8 @@
         </p:nvSpPr>
         <p:spPr>
           <a:xfrm>
-            <a:off x="4206240" y="2834640"/>
-            <a:ext cx="3657600" cy="1463040"/>
+            <a:off x="274320" y="2880360"/>
+            <a:ext cx="2743200" cy="1463040"/>
           </a:xfrm>
           <a:prstGeom prst="roundRect">
             <a:avLst/>
@@ -3027,31 +3116,31 @@
         </p:nvSpPr>
         <p:spPr>
           <a:xfrm>
-            <a:off x="4343400" y="2971800"/>
-            <a:ext cx="640080" cy="640080"/>
-          </a:xfrm>
-          <a:prstGeom prst="rect">
-            <a:avLst/>
-          </a:prstGeom>
-          <a:noFill/>
-          <a:ln/>
-        </p:spPr>
-        <p:txBody>
-          <a:bodyPr wrap="square" rtlCol="0" anchor="ctr"/>
-          <a:lstStyle/>
-          <a:p>
-            <a:pPr indent="0" marL="0">
-              <a:buNone/>
-            </a:pPr>
-            <a:r>
-              <a:rPr lang="en-US" sz="2200" dirty="0">
+            <a:off x="411480" y="2990088"/>
+            <a:ext cx="457200" cy="411480"/>
+          </a:xfrm>
+          <a:prstGeom prst="rect">
+            <a:avLst/>
+          </a:prstGeom>
+          <a:noFill/>
+          <a:ln/>
+        </p:spPr>
+        <p:txBody>
+          <a:bodyPr wrap="square" rtlCol="0" anchor="ctr"/>
+          <a:lstStyle/>
+          <a:p>
+            <a:pPr indent="0" marL="0">
+              <a:buNone/>
+            </a:pPr>
+            <a:r>
+              <a:rPr lang="en-US" sz="1800" dirty="0">
                 <a:solidFill>
                   <a:srgbClr val="000000"/>
                 </a:solidFill>
               </a:rPr>
               <a:t>⚠️</a:t>
             </a:r>
-            <a:endParaRPr lang="en-US" sz="2200" dirty="0"/>
+            <a:endParaRPr lang="en-US" sz="1800" dirty="0"/>
           </a:p>
         </p:txBody>
       </p:sp>
@@ -3063,31 +3152,31 @@
         </p:nvSpPr>
         <p:spPr>
           <a:xfrm>
-            <a:off x="5029200" y="2971800"/>
-            <a:ext cx="2651760" cy="365760"/>
-          </a:xfrm>
-          <a:prstGeom prst="rect">
-            <a:avLst/>
-          </a:prstGeom>
-          <a:noFill/>
-          <a:ln/>
-        </p:spPr>
-        <p:txBody>
-          <a:bodyPr wrap="square" rtlCol="0" anchor="ctr"/>
-          <a:lstStyle/>
-          <a:p>
-            <a:pPr indent="0" marL="0">
-              <a:buNone/>
-            </a:pPr>
-            <a:r>
-              <a:rPr lang="en-US" sz="1200" b="1" dirty="0">
+            <a:off x="914400" y="2990088"/>
+            <a:ext cx="2011680" cy="411480"/>
+          </a:xfrm>
+          <a:prstGeom prst="rect">
+            <a:avLst/>
+          </a:prstGeom>
+          <a:noFill/>
+          <a:ln/>
+        </p:spPr>
+        <p:txBody>
+          <a:bodyPr wrap="square" rtlCol="0" anchor="ctr"/>
+          <a:lstStyle/>
+          <a:p>
+            <a:pPr indent="0" marL="0">
+              <a:buNone/>
+            </a:pPr>
+            <a:r>
+              <a:rPr lang="en-US" sz="1100" b="1" dirty="0">
                 <a:solidFill>
                   <a:srgbClr val="1E293B"/>
                 </a:solidFill>
               </a:rPr>
               <a:t>Absences &amp; Sanctions</a:t>
             </a:r>
-            <a:endParaRPr lang="en-US" sz="1200" dirty="0"/>
+            <a:endParaRPr lang="en-US" sz="1100" dirty="0"/>
           </a:p>
         </p:txBody>
       </p:sp>
@@ -3099,31 +3188,31 @@
         </p:nvSpPr>
         <p:spPr>
           <a:xfrm>
-            <a:off x="5029200" y="3337560"/>
-            <a:ext cx="2651760" cy="731520"/>
-          </a:xfrm>
-          <a:prstGeom prst="rect">
-            <a:avLst/>
-          </a:prstGeom>
-          <a:noFill/>
-          <a:ln/>
-        </p:spPr>
-        <p:txBody>
-          <a:bodyPr wrap="square" rtlCol="0" anchor="ctr"/>
-          <a:lstStyle/>
-          <a:p>
-            <a:pPr indent="0" marL="0">
-              <a:buNone/>
-            </a:pPr>
-            <a:r>
-              <a:rPr lang="en-US" sz="950" dirty="0">
+            <a:off x="411480" y="3447288"/>
+            <a:ext cx="2468880" cy="777240"/>
+          </a:xfrm>
+          <a:prstGeom prst="rect">
+            <a:avLst/>
+          </a:prstGeom>
+          <a:noFill/>
+          <a:ln/>
+        </p:spPr>
+        <p:txBody>
+          <a:bodyPr wrap="square" rtlCol="0" anchor="ctr"/>
+          <a:lstStyle/>
+          <a:p>
+            <a:pPr indent="0" marL="0">
+              <a:buNone/>
+            </a:pPr>
+            <a:r>
+              <a:rPr lang="en-US" sz="900" dirty="0">
                 <a:solidFill>
                   <a:srgbClr val="64748B"/>
                 </a:solidFill>
               </a:rPr>
-              <a:t>Appel de présence, sanctions auto, suivi des amendes</a:t>
-            </a:r>
-            <a:endParaRPr lang="en-US" sz="950" dirty="0"/>
+              <a:t>Grille configurable, sanctions auto, suivi des amendes</a:t>
+            </a:r>
+            <a:endParaRPr lang="en-US" sz="900" dirty="0"/>
           </a:p>
         </p:txBody>
       </p:sp>
@@ -3135,8 +3224,8 @@
         </p:nvSpPr>
         <p:spPr>
           <a:xfrm>
-            <a:off x="8138160" y="2834640"/>
-            <a:ext cx="3657600" cy="1463040"/>
+            <a:off x="3246120" y="2880360"/>
+            <a:ext cx="2743200" cy="1463040"/>
           </a:xfrm>
           <a:prstGeom prst="roundRect">
             <a:avLst/>
@@ -3160,31 +3249,31 @@
         </p:nvSpPr>
         <p:spPr>
           <a:xfrm>
-            <a:off x="8275320" y="2971800"/>
-            <a:ext cx="640080" cy="640080"/>
-          </a:xfrm>
-          <a:prstGeom prst="rect">
-            <a:avLst/>
-          </a:prstGeom>
-          <a:noFill/>
-          <a:ln/>
-        </p:spPr>
-        <p:txBody>
-          <a:bodyPr wrap="square" rtlCol="0" anchor="ctr"/>
-          <a:lstStyle/>
-          <a:p>
-            <a:pPr indent="0" marL="0">
-              <a:buNone/>
-            </a:pPr>
-            <a:r>
-              <a:rPr lang="en-US" sz="2200" dirty="0">
+            <a:off x="3383280" y="2990088"/>
+            <a:ext cx="457200" cy="411480"/>
+          </a:xfrm>
+          <a:prstGeom prst="rect">
+            <a:avLst/>
+          </a:prstGeom>
+          <a:noFill/>
+          <a:ln/>
+        </p:spPr>
+        <p:txBody>
+          <a:bodyPr wrap="square" rtlCol="0" anchor="ctr"/>
+          <a:lstStyle/>
+          <a:p>
+            <a:pPr indent="0" marL="0">
+              <a:buNone/>
+            </a:pPr>
+            <a:r>
+              <a:rPr lang="en-US" sz="1800" dirty="0">
                 <a:solidFill>
                   <a:srgbClr val="000000"/>
                 </a:solidFill>
               </a:rPr>
               <a:t>🤝</a:t>
             </a:r>
-            <a:endParaRPr lang="en-US" sz="2200" dirty="0"/>
+            <a:endParaRPr lang="en-US" sz="1800" dirty="0"/>
           </a:p>
         </p:txBody>
       </p:sp>
@@ -3196,31 +3285,31 @@
         </p:nvSpPr>
         <p:spPr>
           <a:xfrm>
-            <a:off x="8961120" y="2971800"/>
-            <a:ext cx="2651760" cy="365760"/>
-          </a:xfrm>
-          <a:prstGeom prst="rect">
-            <a:avLst/>
-          </a:prstGeom>
-          <a:noFill/>
-          <a:ln/>
-        </p:spPr>
-        <p:txBody>
-          <a:bodyPr wrap="square" rtlCol="0" anchor="ctr"/>
-          <a:lstStyle/>
-          <a:p>
-            <a:pPr indent="0" marL="0">
-              <a:buNone/>
-            </a:pPr>
-            <a:r>
-              <a:rPr lang="en-US" sz="1200" b="1" dirty="0">
+            <a:off x="3886200" y="2990088"/>
+            <a:ext cx="2011680" cy="411480"/>
+          </a:xfrm>
+          <a:prstGeom prst="rect">
+            <a:avLst/>
+          </a:prstGeom>
+          <a:noFill/>
+          <a:ln/>
+        </p:spPr>
+        <p:txBody>
+          <a:bodyPr wrap="square" rtlCol="0" anchor="ctr"/>
+          <a:lstStyle/>
+          <a:p>
+            <a:pPr indent="0" marL="0">
+              <a:buNone/>
+            </a:pPr>
+            <a:r>
+              <a:rPr lang="en-US" sz="1100" b="1" dirty="0">
                 <a:solidFill>
                   <a:srgbClr val="1E293B"/>
                 </a:solidFill>
               </a:rPr>
-              <a:t>Fond de solidarité</a:t>
-            </a:r>
-            <a:endParaRPr lang="en-US" sz="1200" dirty="0"/>
+              <a:t>Aides sur barème</a:t>
+            </a:r>
+            <a:endParaRPr lang="en-US" sz="1100" dirty="0"/>
           </a:p>
         </p:txBody>
       </p:sp>
@@ -3232,31 +3321,31 @@
         </p:nvSpPr>
         <p:spPr>
           <a:xfrm>
-            <a:off x="8961120" y="3337560"/>
-            <a:ext cx="2651760" cy="731520"/>
-          </a:xfrm>
-          <a:prstGeom prst="rect">
-            <a:avLst/>
-          </a:prstGeom>
-          <a:noFill/>
-          <a:ln/>
-        </p:spPr>
-        <p:txBody>
-          <a:bodyPr wrap="square" rtlCol="0" anchor="ctr"/>
-          <a:lstStyle/>
-          <a:p>
-            <a:pPr indent="0" marL="0">
-              <a:buNone/>
-            </a:pPr>
-            <a:r>
-              <a:rPr lang="en-US" sz="950" dirty="0">
+            <a:off x="3383280" y="3447288"/>
+            <a:ext cx="2468880" cy="777240"/>
+          </a:xfrm>
+          <a:prstGeom prst="rect">
+            <a:avLst/>
+          </a:prstGeom>
+          <a:noFill/>
+          <a:ln/>
+        </p:spPr>
+        <p:txBody>
+          <a:bodyPr wrap="square" rtlCol="0" anchor="ctr"/>
+          <a:lstStyle/>
+          <a:p>
+            <a:pPr indent="0" marL="0">
+              <a:buNone/>
+            </a:pPr>
+            <a:r>
+              <a:rPr lang="en-US" sz="900" dirty="0">
                 <a:solidFill>
                   <a:srgbClr val="64748B"/>
                 </a:solidFill>
               </a:rPr>
-              <a:t>Mensuel ou par session, gestion des dettes, projets</a:t>
-            </a:r>
-            <a:endParaRPr lang="en-US" sz="950" dirty="0"/>
+              <a:t>Barème par tontine, demande, activation, collecte des parts</a:t>
+            </a:r>
+            <a:endParaRPr lang="en-US" sz="900" dirty="0"/>
           </a:p>
         </p:txBody>
       </p:sp>
@@ -3268,8 +3357,8 @@
         </p:nvSpPr>
         <p:spPr>
           <a:xfrm>
-            <a:off x="274320" y="4480560"/>
-            <a:ext cx="3657600" cy="1463040"/>
+            <a:off x="6217920" y="2880360"/>
+            <a:ext cx="2743200" cy="1463040"/>
           </a:xfrm>
           <a:prstGeom prst="roundRect">
             <a:avLst/>
@@ -3293,31 +3382,31 @@
         </p:nvSpPr>
         <p:spPr>
           <a:xfrm>
-            <a:off x="411480" y="4617720"/>
-            <a:ext cx="640080" cy="640080"/>
-          </a:xfrm>
-          <a:prstGeom prst="rect">
-            <a:avLst/>
-          </a:prstGeom>
-          <a:noFill/>
-          <a:ln/>
-        </p:spPr>
-        <p:txBody>
-          <a:bodyPr wrap="square" rtlCol="0" anchor="ctr"/>
-          <a:lstStyle/>
-          <a:p>
-            <a:pPr indent="0" marL="0">
-              <a:buNone/>
-            </a:pPr>
-            <a:r>
-              <a:rPr lang="en-US" sz="2200" dirty="0">
+            <a:off x="6355080" y="2990088"/>
+            <a:ext cx="457200" cy="411480"/>
+          </a:xfrm>
+          <a:prstGeom prst="rect">
+            <a:avLst/>
+          </a:prstGeom>
+          <a:noFill/>
+          <a:ln/>
+        </p:spPr>
+        <p:txBody>
+          <a:bodyPr wrap="square" rtlCol="0" anchor="ctr"/>
+          <a:lstStyle/>
+          <a:p>
+            <a:pPr indent="0" marL="0">
+              <a:buNone/>
+            </a:pPr>
+            <a:r>
+              <a:rPr lang="en-US" sz="1800" dirty="0">
                 <a:solidFill>
                   <a:srgbClr val="000000"/>
                 </a:solidFill>
               </a:rPr>
               <a:t>📊</a:t>
             </a:r>
-            <a:endParaRPr lang="en-US" sz="2200" dirty="0"/>
+            <a:endParaRPr lang="en-US" sz="1800" dirty="0"/>
           </a:p>
         </p:txBody>
       </p:sp>
@@ -3329,31 +3418,31 @@
         </p:nvSpPr>
         <p:spPr>
           <a:xfrm>
-            <a:off x="1097280" y="4617720"/>
-            <a:ext cx="2651760" cy="365760"/>
-          </a:xfrm>
-          <a:prstGeom prst="rect">
-            <a:avLst/>
-          </a:prstGeom>
-          <a:noFill/>
-          <a:ln/>
-        </p:spPr>
-        <p:txBody>
-          <a:bodyPr wrap="square" rtlCol="0" anchor="ctr"/>
-          <a:lstStyle/>
-          <a:p>
-            <a:pPr indent="0" marL="0">
-              <a:buNone/>
-            </a:pPr>
-            <a:r>
-              <a:rPr lang="en-US" sz="1200" b="1" dirty="0">
+            <a:off x="6858000" y="2990088"/>
+            <a:ext cx="2011680" cy="411480"/>
+          </a:xfrm>
+          <a:prstGeom prst="rect">
+            <a:avLst/>
+          </a:prstGeom>
+          <a:noFill/>
+          <a:ln/>
+        </p:spPr>
+        <p:txBody>
+          <a:bodyPr wrap="square" rtlCol="0" anchor="ctr"/>
+          <a:lstStyle/>
+          <a:p>
+            <a:pPr indent="0" marL="0">
+              <a:buNone/>
+            </a:pPr>
+            <a:r>
+              <a:rPr lang="en-US" sz="1100" b="1" dirty="0">
                 <a:solidFill>
                   <a:srgbClr val="1E293B"/>
                 </a:solidFill>
               </a:rPr>
               <a:t>Suivi mensuel</a:t>
             </a:r>
-            <a:endParaRPr lang="en-US" sz="1200" dirty="0"/>
+            <a:endParaRPr lang="en-US" sz="1100" dirty="0"/>
           </a:p>
         </p:txBody>
       </p:sp>
@@ -3365,31 +3454,31 @@
         </p:nvSpPr>
         <p:spPr>
           <a:xfrm>
-            <a:off x="1097280" y="4983480"/>
-            <a:ext cx="2651760" cy="731520"/>
-          </a:xfrm>
-          <a:prstGeom prst="rect">
-            <a:avLst/>
-          </a:prstGeom>
-          <a:noFill/>
-          <a:ln/>
-        </p:spPr>
-        <p:txBody>
-          <a:bodyPr wrap="square" rtlCol="0" anchor="ctr"/>
-          <a:lstStyle/>
-          <a:p>
-            <a:pPr indent="0" marL="0">
-              <a:buNone/>
-            </a:pPr>
-            <a:r>
-              <a:rPr lang="en-US" sz="950" dirty="0">
+            <a:off x="6355080" y="3447288"/>
+            <a:ext cx="2468880" cy="777240"/>
+          </a:xfrm>
+          <a:prstGeom prst="rect">
+            <a:avLst/>
+          </a:prstGeom>
+          <a:noFill/>
+          <a:ln/>
+        </p:spPr>
+        <p:txBody>
+          <a:bodyPr wrap="square" rtlCol="0" anchor="ctr"/>
+          <a:lstStyle/>
+          <a:p>
+            <a:pPr indent="0" marL="0">
+              <a:buNone/>
+            </a:pPr>
+            <a:r>
+              <a:rPr lang="en-US" sz="900" dirty="0">
                 <a:solidFill>
                   <a:srgbClr val="64748B"/>
                 </a:solidFill>
               </a:rPr>
               <a:t>Vue synthétique par mois : cotis., épargne, prêts</a:t>
             </a:r>
-            <a:endParaRPr lang="en-US" sz="950" dirty="0"/>
+            <a:endParaRPr lang="en-US" sz="900" dirty="0"/>
           </a:p>
         </p:txBody>
       </p:sp>
@@ -3401,8 +3490,8 @@
         </p:nvSpPr>
         <p:spPr>
           <a:xfrm>
-            <a:off x="4206240" y="4480560"/>
-            <a:ext cx="3657600" cy="1463040"/>
+            <a:off x="9189720" y="2880360"/>
+            <a:ext cx="2743200" cy="1463040"/>
           </a:xfrm>
           <a:prstGeom prst="roundRect">
             <a:avLst/>
@@ -3426,31 +3515,31 @@
         </p:nvSpPr>
         <p:spPr>
           <a:xfrm>
-            <a:off x="4343400" y="4617720"/>
-            <a:ext cx="640080" cy="640080"/>
-          </a:xfrm>
-          <a:prstGeom prst="rect">
-            <a:avLst/>
-          </a:prstGeom>
-          <a:noFill/>
-          <a:ln/>
-        </p:spPr>
-        <p:txBody>
-          <a:bodyPr wrap="square" rtlCol="0" anchor="ctr"/>
-          <a:lstStyle/>
-          <a:p>
-            <a:pPr indent="0" marL="0">
-              <a:buNone/>
-            </a:pPr>
-            <a:r>
-              <a:rPr lang="en-US" sz="2200" dirty="0">
+            <a:off x="9326880" y="2990088"/>
+            <a:ext cx="457200" cy="411480"/>
+          </a:xfrm>
+          <a:prstGeom prst="rect">
+            <a:avLst/>
+          </a:prstGeom>
+          <a:noFill/>
+          <a:ln/>
+        </p:spPr>
+        <p:txBody>
+          <a:bodyPr wrap="square" rtlCol="0" anchor="ctr"/>
+          <a:lstStyle/>
+          <a:p>
+            <a:pPr indent="0" marL="0">
+              <a:buNone/>
+            </a:pPr>
+            <a:r>
+              <a:rPr lang="en-US" sz="1800" dirty="0">
                 <a:solidFill>
                   <a:srgbClr val="000000"/>
                 </a:solidFill>
               </a:rPr>
               <a:t>📤</a:t>
             </a:r>
-            <a:endParaRPr lang="en-US" sz="2200" dirty="0"/>
+            <a:endParaRPr lang="en-US" sz="1800" dirty="0"/>
           </a:p>
         </p:txBody>
       </p:sp>
@@ -3462,31 +3551,31 @@
         </p:nvSpPr>
         <p:spPr>
           <a:xfrm>
-            <a:off x="5029200" y="4617720"/>
-            <a:ext cx="2651760" cy="365760"/>
-          </a:xfrm>
-          <a:prstGeom prst="rect">
-            <a:avLst/>
-          </a:prstGeom>
-          <a:noFill/>
-          <a:ln/>
-        </p:spPr>
-        <p:txBody>
-          <a:bodyPr wrap="square" rtlCol="0" anchor="ctr"/>
-          <a:lstStyle/>
-          <a:p>
-            <a:pPr indent="0" marL="0">
-              <a:buNone/>
-            </a:pPr>
-            <a:r>
-              <a:rPr lang="en-US" sz="1200" b="1" dirty="0">
+            <a:off x="9829800" y="2990088"/>
+            <a:ext cx="2011680" cy="411480"/>
+          </a:xfrm>
+          <a:prstGeom prst="rect">
+            <a:avLst/>
+          </a:prstGeom>
+          <a:noFill/>
+          <a:ln/>
+        </p:spPr>
+        <p:txBody>
+          <a:bodyPr wrap="square" rtlCol="0" anchor="ctr"/>
+          <a:lstStyle/>
+          <a:p>
+            <a:pPr indent="0" marL="0">
+              <a:buNone/>
+            </a:pPr>
+            <a:r>
+              <a:rPr lang="en-US" sz="1100" b="1" dirty="0">
                 <a:solidFill>
                   <a:srgbClr val="1E293B"/>
                 </a:solidFill>
               </a:rPr>
               <a:t>Rattrapage historique</a:t>
             </a:r>
-            <a:endParaRPr lang="en-US" sz="1200" dirty="0"/>
+            <a:endParaRPr lang="en-US" sz="1100" dirty="0"/>
           </a:p>
         </p:txBody>
       </p:sp>
@@ -3498,31 +3587,31 @@
         </p:nvSpPr>
         <p:spPr>
           <a:xfrm>
-            <a:off x="5029200" y="4983480"/>
-            <a:ext cx="2651760" cy="731520"/>
-          </a:xfrm>
-          <a:prstGeom prst="rect">
-            <a:avLst/>
-          </a:prstGeom>
-          <a:noFill/>
-          <a:ln/>
-        </p:spPr>
-        <p:txBody>
-          <a:bodyPr wrap="square" rtlCol="0" anchor="ctr"/>
-          <a:lstStyle/>
-          <a:p>
-            <a:pPr indent="0" marL="0">
-              <a:buNone/>
-            </a:pPr>
-            <a:r>
-              <a:rPr lang="en-US" sz="950" dirty="0">
+            <a:off x="9326880" y="3447288"/>
+            <a:ext cx="2468880" cy="777240"/>
+          </a:xfrm>
+          <a:prstGeom prst="rect">
+            <a:avLst/>
+          </a:prstGeom>
+          <a:noFill/>
+          <a:ln/>
+        </p:spPr>
+        <p:txBody>
+          <a:bodyPr wrap="square" rtlCol="0" anchor="ctr"/>
+          <a:lstStyle/>
+          <a:p>
+            <a:pPr indent="0" marL="0">
+              <a:buNone/>
+            </a:pPr>
+            <a:r>
+              <a:rPr lang="en-US" sz="900" dirty="0">
                 <a:solidFill>
                   <a:srgbClr val="64748B"/>
                 </a:solidFill>
               </a:rPr>
               <a:t>Import Excel pour tontines déjà en cours</a:t>
             </a:r>
-            <a:endParaRPr lang="en-US" sz="950" dirty="0"/>
+            <a:endParaRPr lang="en-US" sz="900" dirty="0"/>
           </a:p>
         </p:txBody>
       </p:sp>
@@ -3534,8 +3623,8 @@
         </p:nvSpPr>
         <p:spPr>
           <a:xfrm>
-            <a:off x="8138160" y="4480560"/>
-            <a:ext cx="3657600" cy="1463040"/>
+            <a:off x="274320" y="4572000"/>
+            <a:ext cx="2743200" cy="1463040"/>
           </a:xfrm>
           <a:prstGeom prst="roundRect">
             <a:avLst/>
@@ -3559,31 +3648,31 @@
         </p:nvSpPr>
         <p:spPr>
           <a:xfrm>
-            <a:off x="8275320" y="4617720"/>
-            <a:ext cx="640080" cy="640080"/>
-          </a:xfrm>
-          <a:prstGeom prst="rect">
-            <a:avLst/>
-          </a:prstGeom>
-          <a:noFill/>
-          <a:ln/>
-        </p:spPr>
-        <p:txBody>
-          <a:bodyPr wrap="square" rtlCol="0" anchor="ctr"/>
-          <a:lstStyle/>
-          <a:p>
-            <a:pPr indent="0" marL="0">
-              <a:buNone/>
-            </a:pPr>
-            <a:r>
-              <a:rPr lang="en-US" sz="2200" dirty="0">
+            <a:off x="411480" y="4681728"/>
+            <a:ext cx="457200" cy="411480"/>
+          </a:xfrm>
+          <a:prstGeom prst="rect">
+            <a:avLst/>
+          </a:prstGeom>
+          <a:noFill/>
+          <a:ln/>
+        </p:spPr>
+        <p:txBody>
+          <a:bodyPr wrap="square" rtlCol="0" anchor="ctr"/>
+          <a:lstStyle/>
+          <a:p>
+            <a:pPr indent="0" marL="0">
+              <a:buNone/>
+            </a:pPr>
+            <a:r>
+              <a:rPr lang="en-US" sz="1800" dirty="0">
                 <a:solidFill>
                   <a:srgbClr val="000000"/>
                 </a:solidFill>
               </a:rPr>
               <a:t>🔗</a:t>
             </a:r>
-            <a:endParaRPr lang="en-US" sz="2200" dirty="0"/>
+            <a:endParaRPr lang="en-US" sz="1800" dirty="0"/>
           </a:p>
         </p:txBody>
       </p:sp>
@@ -3595,31 +3684,31 @@
         </p:nvSpPr>
         <p:spPr>
           <a:xfrm>
-            <a:off x="8961120" y="4617720"/>
-            <a:ext cx="2651760" cy="365760"/>
-          </a:xfrm>
-          <a:prstGeom prst="rect">
-            <a:avLst/>
-          </a:prstGeom>
-          <a:noFill/>
-          <a:ln/>
-        </p:spPr>
-        <p:txBody>
-          <a:bodyPr wrap="square" rtlCol="0" anchor="ctr"/>
-          <a:lstStyle/>
-          <a:p>
-            <a:pPr indent="0" marL="0">
-              <a:buNone/>
-            </a:pPr>
-            <a:r>
-              <a:rPr lang="en-US" sz="1200" b="1" dirty="0">
+            <a:off x="914400" y="4681728"/>
+            <a:ext cx="2011680" cy="411480"/>
+          </a:xfrm>
+          <a:prstGeom prst="rect">
+            <a:avLst/>
+          </a:prstGeom>
+          <a:noFill/>
+          <a:ln/>
+        </p:spPr>
+        <p:txBody>
+          <a:bodyPr wrap="square" rtlCol="0" anchor="ctr"/>
+          <a:lstStyle/>
+          <a:p>
+            <a:pPr indent="0" marL="0">
+              <a:buNone/>
+            </a:pPr>
+            <a:r>
+              <a:rPr lang="en-US" sz="1100" b="1" dirty="0">
                 <a:solidFill>
                   <a:srgbClr val="1E293B"/>
                 </a:solidFill>
               </a:rPr>
               <a:t>Invitations par lien</a:t>
             </a:r>
-            <a:endParaRPr lang="en-US" sz="1200" dirty="0"/>
+            <a:endParaRPr lang="en-US" sz="1100" dirty="0"/>
           </a:p>
         </p:txBody>
       </p:sp>
@@ -3631,37 +3720,436 @@
         </p:nvSpPr>
         <p:spPr>
           <a:xfrm>
-            <a:off x="8961120" y="4983480"/>
-            <a:ext cx="2651760" cy="731520"/>
-          </a:xfrm>
-          <a:prstGeom prst="rect">
-            <a:avLst/>
-          </a:prstGeom>
-          <a:noFill/>
-          <a:ln/>
-        </p:spPr>
-        <p:txBody>
-          <a:bodyPr wrap="square" rtlCol="0" anchor="ctr"/>
-          <a:lstStyle/>
-          <a:p>
-            <a:pPr indent="0" marL="0">
-              <a:buNone/>
-            </a:pPr>
-            <a:r>
-              <a:rPr lang="en-US" sz="950" dirty="0">
+            <a:off x="411480" y="5138928"/>
+            <a:ext cx="2468880" cy="777240"/>
+          </a:xfrm>
+          <a:prstGeom prst="rect">
+            <a:avLst/>
+          </a:prstGeom>
+          <a:noFill/>
+          <a:ln/>
+        </p:spPr>
+        <p:txBody>
+          <a:bodyPr wrap="square" rtlCol="0" anchor="ctr"/>
+          <a:lstStyle/>
+          <a:p>
+            <a:pPr indent="0" marL="0">
+              <a:buNone/>
+            </a:pPr>
+            <a:r>
+              <a:rPr lang="en-US" sz="900" dirty="0">
                 <a:solidFill>
                   <a:srgbClr val="64748B"/>
                 </a:solidFill>
               </a:rPr>
-              <a:t>SMS/WhatsApp, compte créé en 1 minute</a:t>
-            </a:r>
-            <a:endParaRPr lang="en-US" sz="950" dirty="0"/>
-          </a:p>
-        </p:txBody>
-      </p:sp>
-      <p:sp>
-        <p:nvSpPr>
-          <p:cNvPr id="40" name="Text 38"/>
+              <a:t>SMS/WhatsApp, connexion par email ou téléphone</a:t>
+            </a:r>
+            <a:endParaRPr lang="en-US" sz="900" dirty="0"/>
+          </a:p>
+        </p:txBody>
+      </p:sp>
+      <p:sp>
+        <p:nvSpPr>
+          <p:cNvPr id="40" name="Shape 38"/>
+          <p:cNvSpPr/>
+          <p:nvPr/>
+        </p:nvSpPr>
+        <p:spPr>
+          <a:xfrm>
+            <a:off x="3246120" y="4572000"/>
+            <a:ext cx="2743200" cy="1463040"/>
+          </a:xfrm>
+          <a:prstGeom prst="roundRect">
+            <a:avLst/>
+          </a:prstGeom>
+          <a:solidFill>
+            <a:srgbClr val="FFFFFF"/>
+          </a:solidFill>
+          <a:ln w="12700">
+            <a:solidFill>
+              <a:srgbClr val="E2E8F0"/>
+            </a:solidFill>
+            <a:prstDash val="solid"/>
+          </a:ln>
+        </p:spPr>
+      </p:sp>
+      <p:sp>
+        <p:nvSpPr>
+          <p:cNvPr id="41" name="Text 39"/>
+          <p:cNvSpPr/>
+          <p:nvPr/>
+        </p:nvSpPr>
+        <p:spPr>
+          <a:xfrm>
+            <a:off x="3383280" y="4681728"/>
+            <a:ext cx="457200" cy="411480"/>
+          </a:xfrm>
+          <a:prstGeom prst="rect">
+            <a:avLst/>
+          </a:prstGeom>
+          <a:noFill/>
+          <a:ln/>
+        </p:spPr>
+        <p:txBody>
+          <a:bodyPr wrap="square" rtlCol="0" anchor="ctr"/>
+          <a:lstStyle/>
+          <a:p>
+            <a:pPr indent="0" marL="0">
+              <a:buNone/>
+            </a:pPr>
+            <a:r>
+              <a:rPr lang="en-US" sz="1800" dirty="0">
+                <a:solidFill>
+                  <a:srgbClr val="000000"/>
+                </a:solidFill>
+              </a:rPr>
+              <a:t>⏪</a:t>
+            </a:r>
+            <a:endParaRPr lang="en-US" sz="1800" dirty="0"/>
+          </a:p>
+        </p:txBody>
+      </p:sp>
+      <p:sp>
+        <p:nvSpPr>
+          <p:cNvPr id="42" name="Text 40"/>
+          <p:cNvSpPr/>
+          <p:nvPr/>
+        </p:nvSpPr>
+        <p:spPr>
+          <a:xfrm>
+            <a:off x="3886200" y="4681728"/>
+            <a:ext cx="2011680" cy="411480"/>
+          </a:xfrm>
+          <a:prstGeom prst="rect">
+            <a:avLst/>
+          </a:prstGeom>
+          <a:noFill/>
+          <a:ln/>
+        </p:spPr>
+        <p:txBody>
+          <a:bodyPr wrap="square" rtlCol="0" anchor="ctr"/>
+          <a:lstStyle/>
+          <a:p>
+            <a:pPr indent="0" marL="0">
+              <a:buNone/>
+            </a:pPr>
+            <a:r>
+              <a:rPr lang="en-US" sz="1100" b="1" dirty="0">
+                <a:solidFill>
+                  <a:srgbClr val="1E293B"/>
+                </a:solidFill>
+              </a:rPr>
+              <a:t>Reprise en cours</a:t>
+            </a:r>
+            <a:endParaRPr lang="en-US" sz="1100" dirty="0"/>
+          </a:p>
+        </p:txBody>
+      </p:sp>
+      <p:sp>
+        <p:nvSpPr>
+          <p:cNvPr id="43" name="Text 41"/>
+          <p:cNvSpPr/>
+          <p:nvPr/>
+        </p:nvSpPr>
+        <p:spPr>
+          <a:xfrm>
+            <a:off x="3383280" y="5138928"/>
+            <a:ext cx="2468880" cy="777240"/>
+          </a:xfrm>
+          <a:prstGeom prst="rect">
+            <a:avLst/>
+          </a:prstGeom>
+          <a:noFill/>
+          <a:ln/>
+        </p:spPr>
+        <p:txBody>
+          <a:bodyPr wrap="square" rtlCol="0" anchor="ctr"/>
+          <a:lstStyle/>
+          <a:p>
+            <a:pPr indent="0" marL="0">
+              <a:buNone/>
+            </a:pPr>
+            <a:r>
+              <a:rPr lang="en-US" sz="900" dirty="0">
+                <a:solidFill>
+                  <a:srgbClr val="64748B"/>
+                </a:solidFill>
+              </a:rPr>
+              <a:t>Assistant de rattrapage mois par mois, tour par tour</a:t>
+            </a:r>
+            <a:endParaRPr lang="en-US" sz="900" dirty="0"/>
+          </a:p>
+        </p:txBody>
+      </p:sp>
+      <p:sp>
+        <p:nvSpPr>
+          <p:cNvPr id="44" name="Shape 42"/>
+          <p:cNvSpPr/>
+          <p:nvPr/>
+        </p:nvSpPr>
+        <p:spPr>
+          <a:xfrm>
+            <a:off x="6217920" y="4572000"/>
+            <a:ext cx="2743200" cy="1463040"/>
+          </a:xfrm>
+          <a:prstGeom prst="roundRect">
+            <a:avLst/>
+          </a:prstGeom>
+          <a:solidFill>
+            <a:srgbClr val="FFFFFF"/>
+          </a:solidFill>
+          <a:ln w="12700">
+            <a:solidFill>
+              <a:srgbClr val="E2E8F0"/>
+            </a:solidFill>
+            <a:prstDash val="solid"/>
+          </a:ln>
+        </p:spPr>
+      </p:sp>
+      <p:sp>
+        <p:nvSpPr>
+          <p:cNvPr id="45" name="Text 43"/>
+          <p:cNvSpPr/>
+          <p:nvPr/>
+        </p:nvSpPr>
+        <p:spPr>
+          <a:xfrm>
+            <a:off x="6355080" y="4681728"/>
+            <a:ext cx="457200" cy="411480"/>
+          </a:xfrm>
+          <a:prstGeom prst="rect">
+            <a:avLst/>
+          </a:prstGeom>
+          <a:noFill/>
+          <a:ln/>
+        </p:spPr>
+        <p:txBody>
+          <a:bodyPr wrap="square" rtlCol="0" anchor="ctr"/>
+          <a:lstStyle/>
+          <a:p>
+            <a:pPr indent="0" marL="0">
+              <a:buNone/>
+            </a:pPr>
+            <a:r>
+              <a:rPr lang="en-US" sz="1800" dirty="0">
+                <a:solidFill>
+                  <a:srgbClr val="000000"/>
+                </a:solidFill>
+              </a:rPr>
+              <a:t>📄</a:t>
+            </a:r>
+            <a:endParaRPr lang="en-US" sz="1800" dirty="0"/>
+          </a:p>
+        </p:txBody>
+      </p:sp>
+      <p:sp>
+        <p:nvSpPr>
+          <p:cNvPr id="46" name="Text 44"/>
+          <p:cNvSpPr/>
+          <p:nvPr/>
+        </p:nvSpPr>
+        <p:spPr>
+          <a:xfrm>
+            <a:off x="6858000" y="4681728"/>
+            <a:ext cx="2011680" cy="411480"/>
+          </a:xfrm>
+          <a:prstGeom prst="rect">
+            <a:avLst/>
+          </a:prstGeom>
+          <a:noFill/>
+          <a:ln/>
+        </p:spPr>
+        <p:txBody>
+          <a:bodyPr wrap="square" rtlCol="0" anchor="ctr"/>
+          <a:lstStyle/>
+          <a:p>
+            <a:pPr indent="0" marL="0">
+              <a:buNone/>
+            </a:pPr>
+            <a:r>
+              <a:rPr lang="en-US" sz="1100" b="1" dirty="0">
+                <a:solidFill>
+                  <a:srgbClr val="1E293B"/>
+                </a:solidFill>
+              </a:rPr>
+              <a:t>Rapports PDF</a:t>
+            </a:r>
+            <a:endParaRPr lang="en-US" sz="1100" dirty="0"/>
+          </a:p>
+        </p:txBody>
+      </p:sp>
+      <p:sp>
+        <p:nvSpPr>
+          <p:cNvPr id="47" name="Text 45"/>
+          <p:cNvSpPr/>
+          <p:nvPr/>
+        </p:nvSpPr>
+        <p:spPr>
+          <a:xfrm>
+            <a:off x="6355080" y="5138928"/>
+            <a:ext cx="2468880" cy="777240"/>
+          </a:xfrm>
+          <a:prstGeom prst="rect">
+            <a:avLst/>
+          </a:prstGeom>
+          <a:noFill/>
+          <a:ln/>
+        </p:spPr>
+        <p:txBody>
+          <a:bodyPr wrap="square" rtlCol="0" anchor="ctr"/>
+          <a:lstStyle/>
+          <a:p>
+            <a:pPr indent="0" marL="0">
+              <a:buNone/>
+            </a:pPr>
+            <a:r>
+              <a:rPr lang="en-US" sz="900" dirty="0">
+                <a:solidFill>
+                  <a:srgbClr val="64748B"/>
+                </a:solidFill>
+              </a:rPr>
+              <a:t>Rapport de tour et bilan de fin de session, envoyés par email</a:t>
+            </a:r>
+            <a:endParaRPr lang="en-US" sz="900" dirty="0"/>
+          </a:p>
+        </p:txBody>
+      </p:sp>
+      <p:sp>
+        <p:nvSpPr>
+          <p:cNvPr id="48" name="Shape 46"/>
+          <p:cNvSpPr/>
+          <p:nvPr/>
+        </p:nvSpPr>
+        <p:spPr>
+          <a:xfrm>
+            <a:off x="9189720" y="4572000"/>
+            <a:ext cx="2743200" cy="1463040"/>
+          </a:xfrm>
+          <a:prstGeom prst="roundRect">
+            <a:avLst/>
+          </a:prstGeom>
+          <a:solidFill>
+            <a:srgbClr val="FFFFFF"/>
+          </a:solidFill>
+          <a:ln w="12700">
+            <a:solidFill>
+              <a:srgbClr val="E2E8F0"/>
+            </a:solidFill>
+            <a:prstDash val="solid"/>
+          </a:ln>
+        </p:spPr>
+      </p:sp>
+      <p:sp>
+        <p:nvSpPr>
+          <p:cNvPr id="49" name="Text 47"/>
+          <p:cNvSpPr/>
+          <p:nvPr/>
+        </p:nvSpPr>
+        <p:spPr>
+          <a:xfrm>
+            <a:off x="9326880" y="4681728"/>
+            <a:ext cx="457200" cy="411480"/>
+          </a:xfrm>
+          <a:prstGeom prst="rect">
+            <a:avLst/>
+          </a:prstGeom>
+          <a:noFill/>
+          <a:ln/>
+        </p:spPr>
+        <p:txBody>
+          <a:bodyPr wrap="square" rtlCol="0" anchor="ctr"/>
+          <a:lstStyle/>
+          <a:p>
+            <a:pPr indent="0" marL="0">
+              <a:buNone/>
+            </a:pPr>
+            <a:r>
+              <a:rPr lang="en-US" sz="1800" dirty="0">
+                <a:solidFill>
+                  <a:srgbClr val="000000"/>
+                </a:solidFill>
+              </a:rPr>
+              <a:t>🎯</a:t>
+            </a:r>
+            <a:endParaRPr lang="en-US" sz="1800" dirty="0"/>
+          </a:p>
+        </p:txBody>
+      </p:sp>
+      <p:sp>
+        <p:nvSpPr>
+          <p:cNvPr id="50" name="Text 48"/>
+          <p:cNvSpPr/>
+          <p:nvPr/>
+        </p:nvSpPr>
+        <p:spPr>
+          <a:xfrm>
+            <a:off x="9829800" y="4681728"/>
+            <a:ext cx="2011680" cy="411480"/>
+          </a:xfrm>
+          <a:prstGeom prst="rect">
+            <a:avLst/>
+          </a:prstGeom>
+          <a:noFill/>
+          <a:ln/>
+        </p:spPr>
+        <p:txBody>
+          <a:bodyPr wrap="square" rtlCol="0" anchor="ctr"/>
+          <a:lstStyle/>
+          <a:p>
+            <a:pPr indent="0" marL="0">
+              <a:buNone/>
+            </a:pPr>
+            <a:r>
+              <a:rPr lang="en-US" sz="1100" b="1" dirty="0">
+                <a:solidFill>
+                  <a:srgbClr val="1E293B"/>
+                </a:solidFill>
+              </a:rPr>
+              <a:t>Tontine à lot</a:t>
+            </a:r>
+            <a:endParaRPr lang="en-US" sz="1100" dirty="0"/>
+          </a:p>
+        </p:txBody>
+      </p:sp>
+      <p:sp>
+        <p:nvSpPr>
+          <p:cNvPr id="51" name="Text 49"/>
+          <p:cNvSpPr/>
+          <p:nvPr/>
+        </p:nvSpPr>
+        <p:spPr>
+          <a:xfrm>
+            <a:off x="9326880" y="5138928"/>
+            <a:ext cx="2468880" cy="777240"/>
+          </a:xfrm>
+          <a:prstGeom prst="rect">
+            <a:avLst/>
+          </a:prstGeom>
+          <a:noFill/>
+          <a:ln/>
+        </p:spPr>
+        <p:txBody>
+          <a:bodyPr wrap="square" rtlCol="0" anchor="ctr"/>
+          <a:lstStyle/>
+          <a:p>
+            <a:pPr indent="0" marL="0">
+              <a:buNone/>
+            </a:pPr>
+            <a:r>
+              <a:rPr lang="en-US" sz="900" dirty="0">
+                <a:solidFill>
+                  <a:srgbClr val="64748B"/>
+                </a:solidFill>
+              </a:rPr>
+              <a:t>Cagnotte, lots partageables, figeage automatique</a:t>
+            </a:r>
+            <a:endParaRPr lang="en-US" sz="900" dirty="0"/>
+          </a:p>
+        </p:txBody>
+      </p:sp>
+      <p:sp>
+        <p:nvSpPr>
+          <p:cNvPr id="52" name="Text 50"/>
           <p:cNvSpPr/>
           <p:nvPr/>
         </p:nvSpPr>
@@ -3689,7 +4177,7 @@
                   <a:srgbClr val="94A3B8"/>
                 </a:solidFill>
               </a:rPr>
-              <a:t>TontinePro v1.0  ·  JumpyTech  ·  © 2026</a:t>
+              <a:t>TontinePro v1.1  ·  JumpyTech  ·  © 2026</a:t>
             </a:r>
             <a:endParaRPr lang="en-US" sz="800" dirty="0"/>
           </a:p>
@@ -3697,7 +4185,7 @@
       </p:sp>
       <p:sp>
         <p:nvSpPr>
-          <p:cNvPr id="41" name="Text 39"/>
+          <p:cNvPr id="53" name="Text 51"/>
           <p:cNvSpPr/>
           <p:nvPr/>
         </p:nvSpPr>
@@ -4663,7 +5151,7 @@
                   <a:srgbClr val="94A3B8"/>
                 </a:solidFill>
               </a:rPr>
-              <a:t>TontinePro v1.0  ·  JumpyTech  ·  © 2026</a:t>
+              <a:t>TontinePro v1.1  ·  JumpyTech  ·  © 2026</a:t>
             </a:r>
             <a:endParaRPr lang="en-US" sz="800" dirty="0"/>
           </a:p>
@@ -5709,7 +6197,7 @@
                   <a:srgbClr val="94A3B8"/>
                 </a:solidFill>
               </a:rPr>
-              <a:t>TontinePro v1.0  ·  JumpyTech  ·  © 2026</a:t>
+              <a:t>TontinePro v1.1  ·  JumpyTech  ·  © 2026</a:t>
             </a:r>
             <a:endParaRPr lang="en-US" sz="800" dirty="0"/>
           </a:p>
@@ -5813,7 +6301,7 @@
                   <a:srgbClr val="4F46E5"/>
                 </a:solidFill>
               </a:rPr>
-              <a:t>SÉCURITÉ &amp; MULTI-TONTINE</a:t>
+              <a:t>AIDES SUR BARÈME</a:t>
             </a:r>
             <a:endParaRPr lang="en-US" sz="1100" dirty="0"/>
           </a:p>
@@ -5849,7 +6337,7 @@
                   <a:srgbClr val="1E293B"/>
                 </a:solidFill>
               </a:rPr>
-              <a:t>Vos données protégées, vos tontines bien séparées</a:t>
+              <a:t>La solidarité du groupe, encadrée et traçable</a:t>
             </a:r>
             <a:endParaRPr lang="en-US" sz="2200" dirty="0"/>
           </a:p>
@@ -5863,18 +6351,18 @@
         </p:nvSpPr>
         <p:spPr>
           <a:xfrm>
-            <a:off x="274320" y="1280160"/>
-            <a:ext cx="3657600" cy="1371600"/>
+            <a:off x="274320" y="1188720"/>
+            <a:ext cx="6858000" cy="4846320"/>
           </a:xfrm>
           <a:prstGeom prst="roundRect">
             <a:avLst/>
           </a:prstGeom>
           <a:solidFill>
-            <a:srgbClr val="EFF6FF"/>
+            <a:srgbClr val="F8FAFC"/>
           </a:solidFill>
           <a:ln w="12700">
             <a:solidFill>
-              <a:srgbClr val="BFDBFE"/>
+              <a:srgbClr val="E2E8F0"/>
             </a:solidFill>
             <a:prstDash val="solid"/>
           </a:ln>
@@ -5888,126 +6376,54 @@
         </p:nvSpPr>
         <p:spPr>
           <a:xfrm>
-            <a:off x="457200" y="1417320"/>
-            <a:ext cx="640080" cy="640080"/>
-          </a:xfrm>
-          <a:prstGeom prst="rect">
-            <a:avLst/>
-          </a:prstGeom>
-          <a:noFill/>
-          <a:ln/>
-        </p:spPr>
-        <p:txBody>
-          <a:bodyPr wrap="square" rtlCol="0" anchor="ctr"/>
-          <a:lstStyle/>
-          <a:p>
-            <a:pPr indent="0" marL="0">
-              <a:buNone/>
-            </a:pPr>
-            <a:r>
-              <a:rPr lang="en-US" sz="2200" dirty="0">
-                <a:solidFill>
-                  <a:srgbClr val="000000"/>
-                </a:solidFill>
-              </a:rPr>
-              <a:t>🔐</a:t>
-            </a:r>
-            <a:endParaRPr lang="en-US" sz="2200" dirty="0"/>
-          </a:p>
-        </p:txBody>
-      </p:sp>
-      <p:sp>
-        <p:nvSpPr>
-          <p:cNvPr id="6" name="Text 4"/>
-          <p:cNvSpPr/>
-          <p:nvPr/>
-        </p:nvSpPr>
-        <p:spPr>
-          <a:xfrm>
-            <a:off x="1097280" y="1417320"/>
-            <a:ext cx="2651760" cy="320040"/>
-          </a:xfrm>
-          <a:prstGeom prst="rect">
-            <a:avLst/>
-          </a:prstGeom>
-          <a:noFill/>
-          <a:ln/>
-        </p:spPr>
-        <p:txBody>
-          <a:bodyPr wrap="square" rtlCol="0" anchor="ctr"/>
-          <a:lstStyle/>
-          <a:p>
-            <a:pPr indent="0" marL="0">
-              <a:buNone/>
-            </a:pPr>
-            <a:r>
-              <a:rPr lang="en-US" sz="1100" b="1" dirty="0">
-                <a:solidFill>
-                  <a:srgbClr val="1D4ED8"/>
-                </a:solidFill>
-              </a:rPr>
-              <a:t>Double authentification</a:t>
-            </a:r>
-            <a:endParaRPr lang="en-US" sz="1100" dirty="0"/>
-          </a:p>
-        </p:txBody>
-      </p:sp>
-      <p:sp>
-        <p:nvSpPr>
-          <p:cNvPr id="7" name="Text 5"/>
-          <p:cNvSpPr/>
-          <p:nvPr/>
-        </p:nvSpPr>
-        <p:spPr>
-          <a:xfrm>
-            <a:off x="1097280" y="1737360"/>
-            <a:ext cx="2651760" cy="640080"/>
-          </a:xfrm>
-          <a:prstGeom prst="rect">
-            <a:avLst/>
-          </a:prstGeom>
-          <a:noFill/>
-          <a:ln/>
-        </p:spPr>
-        <p:txBody>
-          <a:bodyPr wrap="square" rtlCol="0" anchor="ctr"/>
-          <a:lstStyle/>
-          <a:p>
-            <a:pPr indent="0" marL="0">
-              <a:buNone/>
-            </a:pPr>
-            <a:r>
-              <a:rPr lang="en-US" sz="1000" dirty="0">
-                <a:solidFill>
-                  <a:srgbClr val="3730A3"/>
-                </a:solidFill>
-              </a:rPr>
-              <a:t>2FA avec Google Authenticator ou Authy</a:t>
-            </a:r>
-            <a:endParaRPr lang="en-US" sz="1000" dirty="0"/>
-          </a:p>
-        </p:txBody>
-      </p:sp>
-      <p:sp>
-        <p:nvSpPr>
-          <p:cNvPr id="8" name="Shape 6"/>
-          <p:cNvSpPr/>
-          <p:nvPr/>
-        </p:nvSpPr>
-        <p:spPr>
-          <a:xfrm>
-            <a:off x="4206240" y="1280160"/>
-            <a:ext cx="3657600" cy="1371600"/>
-          </a:xfrm>
-          <a:prstGeom prst="roundRect">
+            <a:off x="457200" y="1280160"/>
+            <a:ext cx="6400800" cy="457200"/>
+          </a:xfrm>
+          <a:prstGeom prst="rect">
+            <a:avLst/>
+          </a:prstGeom>
+          <a:noFill/>
+          <a:ln/>
+        </p:spPr>
+        <p:txBody>
+          <a:bodyPr wrap="square" rtlCol="0" anchor="ctr"/>
+          <a:lstStyle/>
+          <a:p>
+            <a:pPr indent="0" marL="0">
+              <a:buNone/>
+            </a:pPr>
+            <a:r>
+              <a:rPr lang="en-US" sz="1400" b="1" dirty="0">
+                <a:solidFill>
+                  <a:srgbClr val="4F46E5"/>
+                </a:solidFill>
+              </a:rPr>
+              <a:t>Du barème au versement</a:t>
+            </a:r>
+            <a:endParaRPr lang="en-US" sz="1400" dirty="0"/>
+          </a:p>
+        </p:txBody>
+      </p:sp>
+      <p:sp>
+        <p:nvSpPr>
+          <p:cNvPr id="6" name="Shape 4"/>
+          <p:cNvSpPr/>
+          <p:nvPr/>
+        </p:nvSpPr>
+        <p:spPr>
+          <a:xfrm>
+            <a:off x="457200" y="1828800"/>
+            <a:ext cx="457200" cy="457200"/>
+          </a:xfrm>
+          <a:prstGeom prst="ellipse">
             <a:avLst/>
           </a:prstGeom>
           <a:solidFill>
-            <a:srgbClr val="EFF6FF"/>
+            <a:srgbClr val="4F46E5"/>
           </a:solidFill>
           <a:ln w="12700">
             <a:solidFill>
-              <a:srgbClr val="BFDBFE"/>
+              <a:srgbClr val="4F46E5"/>
             </a:solidFill>
             <a:prstDash val="solid"/>
           </a:ln>
@@ -6015,86 +6431,86 @@
       </p:sp>
       <p:sp>
         <p:nvSpPr>
+          <p:cNvPr id="7" name="Text 5"/>
+          <p:cNvSpPr/>
+          <p:nvPr/>
+        </p:nvSpPr>
+        <p:spPr>
+          <a:xfrm>
+            <a:off x="457200" y="1828800"/>
+            <a:ext cx="457200" cy="457200"/>
+          </a:xfrm>
+          <a:prstGeom prst="rect">
+            <a:avLst/>
+          </a:prstGeom>
+          <a:noFill/>
+          <a:ln/>
+        </p:spPr>
+        <p:txBody>
+          <a:bodyPr wrap="square" rtlCol="0" anchor="ctr"/>
+          <a:lstStyle/>
+          <a:p>
+            <a:pPr algn="ctr" indent="0" marL="0">
+              <a:buNone/>
+            </a:pPr>
+            <a:r>
+              <a:rPr lang="en-US" sz="1300" b="1" dirty="0">
+                <a:solidFill>
+                  <a:srgbClr val="FFFFFF"/>
+                </a:solidFill>
+              </a:rPr>
+              <a:t>1</a:t>
+            </a:r>
+            <a:endParaRPr lang="en-US" sz="1300" dirty="0"/>
+          </a:p>
+        </p:txBody>
+      </p:sp>
+      <p:sp>
+        <p:nvSpPr>
+          <p:cNvPr id="8" name="Text 6"/>
+          <p:cNvSpPr/>
+          <p:nvPr/>
+        </p:nvSpPr>
+        <p:spPr>
+          <a:xfrm>
+            <a:off x="1097280" y="1828800"/>
+            <a:ext cx="5760720" cy="274320"/>
+          </a:xfrm>
+          <a:prstGeom prst="rect">
+            <a:avLst/>
+          </a:prstGeom>
+          <a:noFill/>
+          <a:ln/>
+        </p:spPr>
+        <p:txBody>
+          <a:bodyPr wrap="square" rtlCol="0" anchor="ctr"/>
+          <a:lstStyle/>
+          <a:p>
+            <a:pPr indent="0" marL="0">
+              <a:buNone/>
+            </a:pPr>
+            <a:r>
+              <a:rPr lang="en-US" sz="1200" b="1" dirty="0">
+                <a:solidFill>
+                  <a:srgbClr val="1E293B"/>
+                </a:solidFill>
+              </a:rPr>
+              <a:t>Le bureau définit le barème</a:t>
+            </a:r>
+            <a:endParaRPr lang="en-US" sz="1200" dirty="0"/>
+          </a:p>
+        </p:txBody>
+      </p:sp>
+      <p:sp>
+        <p:nvSpPr>
           <p:cNvPr id="9" name="Text 7"/>
           <p:cNvSpPr/>
           <p:nvPr/>
         </p:nvSpPr>
         <p:spPr>
           <a:xfrm>
-            <a:off x="4389120" y="1417320"/>
-            <a:ext cx="640080" cy="640080"/>
-          </a:xfrm>
-          <a:prstGeom prst="rect">
-            <a:avLst/>
-          </a:prstGeom>
-          <a:noFill/>
-          <a:ln/>
-        </p:spPr>
-        <p:txBody>
-          <a:bodyPr wrap="square" rtlCol="0" anchor="ctr"/>
-          <a:lstStyle/>
-          <a:p>
-            <a:pPr indent="0" marL="0">
-              <a:buNone/>
-            </a:pPr>
-            <a:r>
-              <a:rPr lang="en-US" sz="2200" dirty="0">
-                <a:solidFill>
-                  <a:srgbClr val="000000"/>
-                </a:solidFill>
-              </a:rPr>
-              <a:t>🔒</a:t>
-            </a:r>
-            <a:endParaRPr lang="en-US" sz="2200" dirty="0"/>
-          </a:p>
-        </p:txBody>
-      </p:sp>
-      <p:sp>
-        <p:nvSpPr>
-          <p:cNvPr id="10" name="Text 8"/>
-          <p:cNvSpPr/>
-          <p:nvPr/>
-        </p:nvSpPr>
-        <p:spPr>
-          <a:xfrm>
-            <a:off x="5029200" y="1417320"/>
-            <a:ext cx="2651760" cy="320040"/>
-          </a:xfrm>
-          <a:prstGeom prst="rect">
-            <a:avLst/>
-          </a:prstGeom>
-          <a:noFill/>
-          <a:ln/>
-        </p:spPr>
-        <p:txBody>
-          <a:bodyPr wrap="square" rtlCol="0" anchor="ctr"/>
-          <a:lstStyle/>
-          <a:p>
-            <a:pPr indent="0" marL="0">
-              <a:buNone/>
-            </a:pPr>
-            <a:r>
-              <a:rPr lang="en-US" sz="1100" b="1" dirty="0">
-                <a:solidFill>
-                  <a:srgbClr val="1D4ED8"/>
-                </a:solidFill>
-              </a:rPr>
-              <a:t>Tokens JWT sécurisés</a:t>
-            </a:r>
-            <a:endParaRPr lang="en-US" sz="1100" dirty="0"/>
-          </a:p>
-        </p:txBody>
-      </p:sp>
-      <p:sp>
-        <p:nvSpPr>
-          <p:cNvPr id="11" name="Text 9"/>
-          <p:cNvSpPr/>
-          <p:nvPr/>
-        </p:nvSpPr>
-        <p:spPr>
-          <a:xfrm>
-            <a:off x="5029200" y="1737360"/>
-            <a:ext cx="2651760" cy="640080"/>
+            <a:off x="1097280" y="2084832"/>
+            <a:ext cx="5760720" cy="365760"/>
           </a:xfrm>
           <a:prstGeom prst="rect">
             <a:avLst/>
@@ -6112,10 +6528,10 @@
             <a:r>
               <a:rPr lang="en-US" sz="1000" dirty="0">
                 <a:solidFill>
-                  <a:srgbClr val="3730A3"/>
-                </a:solidFill>
-              </a:rPr>
-              <a:t>Sessions à durée limitée, déconnexion immédiate</a:t>
+                  <a:srgbClr val="64748B"/>
+                </a:solidFill>
+              </a:rPr>
+              <a:t>Rubriques propres à la tontine : décès, mariage, naissance…</a:t>
             </a:r>
             <a:endParaRPr lang="en-US" sz="1000" dirty="0"/>
           </a:p>
@@ -6123,24 +6539,24 @@
       </p:sp>
       <p:sp>
         <p:nvSpPr>
-          <p:cNvPr id="12" name="Shape 10"/>
-          <p:cNvSpPr/>
-          <p:nvPr/>
-        </p:nvSpPr>
-        <p:spPr>
-          <a:xfrm>
-            <a:off x="8138160" y="1280160"/>
-            <a:ext cx="3657600" cy="1371600"/>
-          </a:xfrm>
-          <a:prstGeom prst="roundRect">
+          <p:cNvPr id="10" name="Shape 8"/>
+          <p:cNvSpPr/>
+          <p:nvPr/>
+        </p:nvSpPr>
+        <p:spPr>
+          <a:xfrm>
+            <a:off x="457200" y="2834640"/>
+            <a:ext cx="457200" cy="457200"/>
+          </a:xfrm>
+          <a:prstGeom prst="ellipse">
             <a:avLst/>
           </a:prstGeom>
           <a:solidFill>
-            <a:srgbClr val="EFF6FF"/>
+            <a:srgbClr val="4F46E5"/>
           </a:solidFill>
           <a:ln w="12700">
             <a:solidFill>
-              <a:srgbClr val="BFDBFE"/>
+              <a:srgbClr val="4F46E5"/>
             </a:solidFill>
             <a:prstDash val="solid"/>
           </a:ln>
@@ -6148,86 +6564,86 @@
       </p:sp>
       <p:sp>
         <p:nvSpPr>
+          <p:cNvPr id="11" name="Text 9"/>
+          <p:cNvSpPr/>
+          <p:nvPr/>
+        </p:nvSpPr>
+        <p:spPr>
+          <a:xfrm>
+            <a:off x="457200" y="2834640"/>
+            <a:ext cx="457200" cy="457200"/>
+          </a:xfrm>
+          <a:prstGeom prst="rect">
+            <a:avLst/>
+          </a:prstGeom>
+          <a:noFill/>
+          <a:ln/>
+        </p:spPr>
+        <p:txBody>
+          <a:bodyPr wrap="square" rtlCol="0" anchor="ctr"/>
+          <a:lstStyle/>
+          <a:p>
+            <a:pPr algn="ctr" indent="0" marL="0">
+              <a:buNone/>
+            </a:pPr>
+            <a:r>
+              <a:rPr lang="en-US" sz="1300" b="1" dirty="0">
+                <a:solidFill>
+                  <a:srgbClr val="FFFFFF"/>
+                </a:solidFill>
+              </a:rPr>
+              <a:t>2</a:t>
+            </a:r>
+            <a:endParaRPr lang="en-US" sz="1300" dirty="0"/>
+          </a:p>
+        </p:txBody>
+      </p:sp>
+      <p:sp>
+        <p:nvSpPr>
+          <p:cNvPr id="12" name="Text 10"/>
+          <p:cNvSpPr/>
+          <p:nvPr/>
+        </p:nvSpPr>
+        <p:spPr>
+          <a:xfrm>
+            <a:off x="1097280" y="2834640"/>
+            <a:ext cx="5760720" cy="274320"/>
+          </a:xfrm>
+          <a:prstGeom prst="rect">
+            <a:avLst/>
+          </a:prstGeom>
+          <a:noFill/>
+          <a:ln/>
+        </p:spPr>
+        <p:txBody>
+          <a:bodyPr wrap="square" rtlCol="0" anchor="ctr"/>
+          <a:lstStyle/>
+          <a:p>
+            <a:pPr indent="0" marL="0">
+              <a:buNone/>
+            </a:pPr>
+            <a:r>
+              <a:rPr lang="en-US" sz="1200" b="1" dirty="0">
+                <a:solidFill>
+                  <a:srgbClr val="1E293B"/>
+                </a:solidFill>
+              </a:rPr>
+              <a:t>Le membre fait sa demande</a:t>
+            </a:r>
+            <a:endParaRPr lang="en-US" sz="1200" dirty="0"/>
+          </a:p>
+        </p:txBody>
+      </p:sp>
+      <p:sp>
+        <p:nvSpPr>
           <p:cNvPr id="13" name="Text 11"/>
           <p:cNvSpPr/>
           <p:nvPr/>
         </p:nvSpPr>
         <p:spPr>
           <a:xfrm>
-            <a:off x="8321040" y="1417320"/>
-            <a:ext cx="640080" cy="640080"/>
-          </a:xfrm>
-          <a:prstGeom prst="rect">
-            <a:avLst/>
-          </a:prstGeom>
-          <a:noFill/>
-          <a:ln/>
-        </p:spPr>
-        <p:txBody>
-          <a:bodyPr wrap="square" rtlCol="0" anchor="ctr"/>
-          <a:lstStyle/>
-          <a:p>
-            <a:pPr indent="0" marL="0">
-              <a:buNone/>
-            </a:pPr>
-            <a:r>
-              <a:rPr lang="en-US" sz="2200" dirty="0">
-                <a:solidFill>
-                  <a:srgbClr val="000000"/>
-                </a:solidFill>
-              </a:rPr>
-              <a:t>🌐</a:t>
-            </a:r>
-            <a:endParaRPr lang="en-US" sz="2200" dirty="0"/>
-          </a:p>
-        </p:txBody>
-      </p:sp>
-      <p:sp>
-        <p:nvSpPr>
-          <p:cNvPr id="14" name="Text 12"/>
-          <p:cNvSpPr/>
-          <p:nvPr/>
-        </p:nvSpPr>
-        <p:spPr>
-          <a:xfrm>
-            <a:off x="8961120" y="1417320"/>
-            <a:ext cx="2651760" cy="320040"/>
-          </a:xfrm>
-          <a:prstGeom prst="rect">
-            <a:avLst/>
-          </a:prstGeom>
-          <a:noFill/>
-          <a:ln/>
-        </p:spPr>
-        <p:txBody>
-          <a:bodyPr wrap="square" rtlCol="0" anchor="ctr"/>
-          <a:lstStyle/>
-          <a:p>
-            <a:pPr indent="0" marL="0">
-              <a:buNone/>
-            </a:pPr>
-            <a:r>
-              <a:rPr lang="en-US" sz="1100" b="1" dirty="0">
-                <a:solidFill>
-                  <a:srgbClr val="1D4ED8"/>
-                </a:solidFill>
-              </a:rPr>
-              <a:t>HTTPS + CORS strict</a:t>
-            </a:r>
-            <a:endParaRPr lang="en-US" sz="1100" dirty="0"/>
-          </a:p>
-        </p:txBody>
-      </p:sp>
-      <p:sp>
-        <p:nvSpPr>
-          <p:cNvPr id="15" name="Text 13"/>
-          <p:cNvSpPr/>
-          <p:nvPr/>
-        </p:nvSpPr>
-        <p:spPr>
-          <a:xfrm>
-            <a:off x="8961120" y="1737360"/>
-            <a:ext cx="2651760" cy="640080"/>
+            <a:off x="1097280" y="3090672"/>
+            <a:ext cx="5760720" cy="365760"/>
           </a:xfrm>
           <a:prstGeom prst="rect">
             <a:avLst/>
@@ -6245,10 +6661,10 @@
             <a:r>
               <a:rPr lang="en-US" sz="1000" dirty="0">
                 <a:solidFill>
-                  <a:srgbClr val="3730A3"/>
-                </a:solidFill>
-              </a:rPr>
-              <a:t>Communication chiffrée TLS</a:t>
+                  <a:srgbClr val="64748B"/>
+                </a:solidFill>
+              </a:rPr>
+              <a:t>Depuis le barème, avec le montant calculé en direct</a:t>
             </a:r>
             <a:endParaRPr lang="en-US" sz="1000" dirty="0"/>
           </a:p>
@@ -6256,24 +6672,24 @@
       </p:sp>
       <p:sp>
         <p:nvSpPr>
-          <p:cNvPr id="16" name="Shape 14"/>
-          <p:cNvSpPr/>
-          <p:nvPr/>
-        </p:nvSpPr>
-        <p:spPr>
-          <a:xfrm>
-            <a:off x="274320" y="2926080"/>
-            <a:ext cx="3657600" cy="1371600"/>
-          </a:xfrm>
-          <a:prstGeom prst="roundRect">
+          <p:cNvPr id="14" name="Shape 12"/>
+          <p:cNvSpPr/>
+          <p:nvPr/>
+        </p:nvSpPr>
+        <p:spPr>
+          <a:xfrm>
+            <a:off x="457200" y="3840480"/>
+            <a:ext cx="457200" cy="457200"/>
+          </a:xfrm>
+          <a:prstGeom prst="ellipse">
             <a:avLst/>
           </a:prstGeom>
           <a:solidFill>
-            <a:srgbClr val="EFF6FF"/>
+            <a:srgbClr val="4F46E5"/>
           </a:solidFill>
           <a:ln w="12700">
             <a:solidFill>
-              <a:srgbClr val="BFDBFE"/>
+              <a:srgbClr val="4F46E5"/>
             </a:solidFill>
             <a:prstDash val="solid"/>
           </a:ln>
@@ -6281,86 +6697,86 @@
       </p:sp>
       <p:sp>
         <p:nvSpPr>
+          <p:cNvPr id="15" name="Text 13"/>
+          <p:cNvSpPr/>
+          <p:nvPr/>
+        </p:nvSpPr>
+        <p:spPr>
+          <a:xfrm>
+            <a:off x="457200" y="3840480"/>
+            <a:ext cx="457200" cy="457200"/>
+          </a:xfrm>
+          <a:prstGeom prst="rect">
+            <a:avLst/>
+          </a:prstGeom>
+          <a:noFill/>
+          <a:ln/>
+        </p:spPr>
+        <p:txBody>
+          <a:bodyPr wrap="square" rtlCol="0" anchor="ctr"/>
+          <a:lstStyle/>
+          <a:p>
+            <a:pPr algn="ctr" indent="0" marL="0">
+              <a:buNone/>
+            </a:pPr>
+            <a:r>
+              <a:rPr lang="en-US" sz="1300" b="1" dirty="0">
+                <a:solidFill>
+                  <a:srgbClr val="FFFFFF"/>
+                </a:solidFill>
+              </a:rPr>
+              <a:t>3</a:t>
+            </a:r>
+            <a:endParaRPr lang="en-US" sz="1300" dirty="0"/>
+          </a:p>
+        </p:txBody>
+      </p:sp>
+      <p:sp>
+        <p:nvSpPr>
+          <p:cNvPr id="16" name="Text 14"/>
+          <p:cNvSpPr/>
+          <p:nvPr/>
+        </p:nvSpPr>
+        <p:spPr>
+          <a:xfrm>
+            <a:off x="1097280" y="3840480"/>
+            <a:ext cx="5760720" cy="274320"/>
+          </a:xfrm>
+          <a:prstGeom prst="rect">
+            <a:avLst/>
+          </a:prstGeom>
+          <a:noFill/>
+          <a:ln/>
+        </p:spPr>
+        <p:txBody>
+          <a:bodyPr wrap="square" rtlCol="0" anchor="ctr"/>
+          <a:lstStyle/>
+          <a:p>
+            <a:pPr indent="0" marL="0">
+              <a:buNone/>
+            </a:pPr>
+            <a:r>
+              <a:rPr lang="en-US" sz="1200" b="1" dirty="0">
+                <a:solidFill>
+                  <a:srgbClr val="1E293B"/>
+                </a:solidFill>
+              </a:rPr>
+              <a:t>Le bureau active l'aide</a:t>
+            </a:r>
+            <a:endParaRPr lang="en-US" sz="1200" dirty="0"/>
+          </a:p>
+        </p:txBody>
+      </p:sp>
+      <p:sp>
+        <p:nvSpPr>
           <p:cNvPr id="17" name="Text 15"/>
           <p:cNvSpPr/>
           <p:nvPr/>
         </p:nvSpPr>
         <p:spPr>
           <a:xfrm>
-            <a:off x="457200" y="3063240"/>
-            <a:ext cx="640080" cy="640080"/>
-          </a:xfrm>
-          <a:prstGeom prst="rect">
-            <a:avLst/>
-          </a:prstGeom>
-          <a:noFill/>
-          <a:ln/>
-        </p:spPr>
-        <p:txBody>
-          <a:bodyPr wrap="square" rtlCol="0" anchor="ctr"/>
-          <a:lstStyle/>
-          <a:p>
-            <a:pPr indent="0" marL="0">
-              <a:buNone/>
-            </a:pPr>
-            <a:r>
-              <a:rPr lang="en-US" sz="2200" dirty="0">
-                <a:solidFill>
-                  <a:srgbClr val="000000"/>
-                </a:solidFill>
-              </a:rPr>
-              <a:t>🏛️</a:t>
-            </a:r>
-            <a:endParaRPr lang="en-US" sz="2200" dirty="0"/>
-          </a:p>
-        </p:txBody>
-      </p:sp>
-      <p:sp>
-        <p:nvSpPr>
-          <p:cNvPr id="18" name="Text 16"/>
-          <p:cNvSpPr/>
-          <p:nvPr/>
-        </p:nvSpPr>
-        <p:spPr>
-          <a:xfrm>
-            <a:off x="1097280" y="3063240"/>
-            <a:ext cx="2651760" cy="320040"/>
-          </a:xfrm>
-          <a:prstGeom prst="rect">
-            <a:avLst/>
-          </a:prstGeom>
-          <a:noFill/>
-          <a:ln/>
-        </p:spPr>
-        <p:txBody>
-          <a:bodyPr wrap="square" rtlCol="0" anchor="ctr"/>
-          <a:lstStyle/>
-          <a:p>
-            <a:pPr indent="0" marL="0">
-              <a:buNone/>
-            </a:pPr>
-            <a:r>
-              <a:rPr lang="en-US" sz="1100" b="1" dirty="0">
-                <a:solidFill>
-                  <a:srgbClr val="1D4ED8"/>
-                </a:solidFill>
-              </a:rPr>
-              <a:t>Rôles et permissions</a:t>
-            </a:r>
-            <a:endParaRPr lang="en-US" sz="1100" dirty="0"/>
-          </a:p>
-        </p:txBody>
-      </p:sp>
-      <p:sp>
-        <p:nvSpPr>
-          <p:cNvPr id="19" name="Text 17"/>
-          <p:cNvSpPr/>
-          <p:nvPr/>
-        </p:nvSpPr>
-        <p:spPr>
-          <a:xfrm>
-            <a:off x="1097280" y="3383280"/>
-            <a:ext cx="2651760" cy="640080"/>
+            <a:off x="1097280" y="4096512"/>
+            <a:ext cx="5760720" cy="365760"/>
           </a:xfrm>
           <a:prstGeom prst="rect">
             <a:avLst/>
@@ -6378,10 +6794,10 @@
             <a:r>
               <a:rPr lang="en-US" sz="1000" dirty="0">
                 <a:solidFill>
-                  <a:srgbClr val="3730A3"/>
-                </a:solidFill>
-              </a:rPr>
-              <a:t>SUPER_ADMIN · Président · Secrétaire · Membre</a:t>
+                  <a:srgbClr val="64748B"/>
+                </a:solidFill>
+              </a:rPr>
+              <a:t>Contrôle d'éligibilité : limite et portée par rubrique</a:t>
             </a:r>
             <a:endParaRPr lang="en-US" sz="1000" dirty="0"/>
           </a:p>
@@ -6389,24 +6805,24 @@
       </p:sp>
       <p:sp>
         <p:nvSpPr>
-          <p:cNvPr id="20" name="Shape 18"/>
-          <p:cNvSpPr/>
-          <p:nvPr/>
-        </p:nvSpPr>
-        <p:spPr>
-          <a:xfrm>
-            <a:off x="4206240" y="2926080"/>
-            <a:ext cx="3657600" cy="1371600"/>
-          </a:xfrm>
-          <a:prstGeom prst="roundRect">
+          <p:cNvPr id="18" name="Shape 16"/>
+          <p:cNvSpPr/>
+          <p:nvPr/>
+        </p:nvSpPr>
+        <p:spPr>
+          <a:xfrm>
+            <a:off x="457200" y="4846320"/>
+            <a:ext cx="457200" cy="457200"/>
+          </a:xfrm>
+          <a:prstGeom prst="ellipse">
             <a:avLst/>
           </a:prstGeom>
           <a:solidFill>
-            <a:srgbClr val="EFF6FF"/>
+            <a:srgbClr val="4F46E5"/>
           </a:solidFill>
           <a:ln w="12700">
             <a:solidFill>
-              <a:srgbClr val="BFDBFE"/>
+              <a:srgbClr val="4F46E5"/>
             </a:solidFill>
             <a:prstDash val="solid"/>
           </a:ln>
@@ -6414,86 +6830,86 @@
       </p:sp>
       <p:sp>
         <p:nvSpPr>
+          <p:cNvPr id="19" name="Text 17"/>
+          <p:cNvSpPr/>
+          <p:nvPr/>
+        </p:nvSpPr>
+        <p:spPr>
+          <a:xfrm>
+            <a:off x="457200" y="4846320"/>
+            <a:ext cx="457200" cy="457200"/>
+          </a:xfrm>
+          <a:prstGeom prst="rect">
+            <a:avLst/>
+          </a:prstGeom>
+          <a:noFill/>
+          <a:ln/>
+        </p:spPr>
+        <p:txBody>
+          <a:bodyPr wrap="square" rtlCol="0" anchor="ctr"/>
+          <a:lstStyle/>
+          <a:p>
+            <a:pPr algn="ctr" indent="0" marL="0">
+              <a:buNone/>
+            </a:pPr>
+            <a:r>
+              <a:rPr lang="en-US" sz="1300" b="1" dirty="0">
+                <a:solidFill>
+                  <a:srgbClr val="FFFFFF"/>
+                </a:solidFill>
+              </a:rPr>
+              <a:t>4</a:t>
+            </a:r>
+            <a:endParaRPr lang="en-US" sz="1300" dirty="0"/>
+          </a:p>
+        </p:txBody>
+      </p:sp>
+      <p:sp>
+        <p:nvSpPr>
+          <p:cNvPr id="20" name="Text 18"/>
+          <p:cNvSpPr/>
+          <p:nvPr/>
+        </p:nvSpPr>
+        <p:spPr>
+          <a:xfrm>
+            <a:off x="1097280" y="4846320"/>
+            <a:ext cx="5760720" cy="274320"/>
+          </a:xfrm>
+          <a:prstGeom prst="rect">
+            <a:avLst/>
+          </a:prstGeom>
+          <a:noFill/>
+          <a:ln/>
+        </p:spPr>
+        <p:txBody>
+          <a:bodyPr wrap="square" rtlCol="0" anchor="ctr"/>
+          <a:lstStyle/>
+          <a:p>
+            <a:pPr indent="0" marL="0">
+              <a:buNone/>
+            </a:pPr>
+            <a:r>
+              <a:rPr lang="en-US" sz="1200" b="1" dirty="0">
+                <a:solidFill>
+                  <a:srgbClr val="1E293B"/>
+                </a:solidFill>
+              </a:rPr>
+              <a:t>Chaque membre verse sa part</a:t>
+            </a:r>
+            <a:endParaRPr lang="en-US" sz="1200" dirty="0"/>
+          </a:p>
+        </p:txBody>
+      </p:sp>
+      <p:sp>
+        <p:nvSpPr>
           <p:cNvPr id="21" name="Text 19"/>
           <p:cNvSpPr/>
           <p:nvPr/>
         </p:nvSpPr>
         <p:spPr>
           <a:xfrm>
-            <a:off x="4389120" y="3063240"/>
-            <a:ext cx="640080" cy="640080"/>
-          </a:xfrm>
-          <a:prstGeom prst="rect">
-            <a:avLst/>
-          </a:prstGeom>
-          <a:noFill/>
-          <a:ln/>
-        </p:spPr>
-        <p:txBody>
-          <a:bodyPr wrap="square" rtlCol="0" anchor="ctr"/>
-          <a:lstStyle/>
-          <a:p>
-            <a:pPr indent="0" marL="0">
-              <a:buNone/>
-            </a:pPr>
-            <a:r>
-              <a:rPr lang="en-US" sz="2200" dirty="0">
-                <a:solidFill>
-                  <a:srgbClr val="000000"/>
-                </a:solidFill>
-              </a:rPr>
-              <a:t>💾</a:t>
-            </a:r>
-            <a:endParaRPr lang="en-US" sz="2200" dirty="0"/>
-          </a:p>
-        </p:txBody>
-      </p:sp>
-      <p:sp>
-        <p:nvSpPr>
-          <p:cNvPr id="22" name="Text 20"/>
-          <p:cNvSpPr/>
-          <p:nvPr/>
-        </p:nvSpPr>
-        <p:spPr>
-          <a:xfrm>
-            <a:off x="5029200" y="3063240"/>
-            <a:ext cx="2651760" cy="320040"/>
-          </a:xfrm>
-          <a:prstGeom prst="rect">
-            <a:avLst/>
-          </a:prstGeom>
-          <a:noFill/>
-          <a:ln/>
-        </p:spPr>
-        <p:txBody>
-          <a:bodyPr wrap="square" rtlCol="0" anchor="ctr"/>
-          <a:lstStyle/>
-          <a:p>
-            <a:pPr indent="0" marL="0">
-              <a:buNone/>
-            </a:pPr>
-            <a:r>
-              <a:rPr lang="en-US" sz="1100" b="1" dirty="0">
-                <a:solidFill>
-                  <a:srgbClr val="1D4ED8"/>
-                </a:solidFill>
-              </a:rPr>
-              <a:t>Hébergement local</a:t>
-            </a:r>
-            <a:endParaRPr lang="en-US" sz="1100" dirty="0"/>
-          </a:p>
-        </p:txBody>
-      </p:sp>
-      <p:sp>
-        <p:nvSpPr>
-          <p:cNvPr id="23" name="Text 21"/>
-          <p:cNvSpPr/>
-          <p:nvPr/>
-        </p:nvSpPr>
-        <p:spPr>
-          <a:xfrm>
-            <a:off x="5029200" y="3383280"/>
-            <a:ext cx="2651760" cy="640080"/>
+            <a:off x="1097280" y="5102352"/>
+            <a:ext cx="5760720" cy="365760"/>
           </a:xfrm>
           <a:prstGeom prst="rect">
             <a:avLst/>
@@ -6511,10 +6927,10 @@
             <a:r>
               <a:rPr lang="en-US" sz="1000" dirty="0">
                 <a:solidFill>
-                  <a:srgbClr val="3730A3"/>
-                </a:solidFill>
-              </a:rPr>
-              <a:t>Vos données ne transitent pas par des tiers</a:t>
+                  <a:srgbClr val="64748B"/>
+                </a:solidFill>
+              </a:rPr>
+              <a:t>Écran de collecte dédié — matrice membres × aides</a:t>
             </a:r>
             <a:endParaRPr lang="en-US" sz="1000" dirty="0"/>
           </a:p>
@@ -6522,147 +6938,14 @@
       </p:sp>
       <p:sp>
         <p:nvSpPr>
-          <p:cNvPr id="24" name="Shape 22"/>
-          <p:cNvSpPr/>
-          <p:nvPr/>
-        </p:nvSpPr>
-        <p:spPr>
-          <a:xfrm>
-            <a:off x="8138160" y="2926080"/>
-            <a:ext cx="3657600" cy="1371600"/>
-          </a:xfrm>
-          <a:prstGeom prst="roundRect">
-            <a:avLst/>
-          </a:prstGeom>
-          <a:solidFill>
-            <a:srgbClr val="EFF6FF"/>
-          </a:solidFill>
-          <a:ln w="12700">
-            <a:solidFill>
-              <a:srgbClr val="BFDBFE"/>
-            </a:solidFill>
-            <a:prstDash val="solid"/>
-          </a:ln>
-        </p:spPr>
-      </p:sp>
-      <p:sp>
-        <p:nvSpPr>
-          <p:cNvPr id="25" name="Text 23"/>
-          <p:cNvSpPr/>
-          <p:nvPr/>
-        </p:nvSpPr>
-        <p:spPr>
-          <a:xfrm>
-            <a:off x="8321040" y="3063240"/>
-            <a:ext cx="640080" cy="640080"/>
-          </a:xfrm>
-          <a:prstGeom prst="rect">
-            <a:avLst/>
-          </a:prstGeom>
-          <a:noFill/>
-          <a:ln/>
-        </p:spPr>
-        <p:txBody>
-          <a:bodyPr wrap="square" rtlCol="0" anchor="ctr"/>
-          <a:lstStyle/>
-          <a:p>
-            <a:pPr indent="0" marL="0">
-              <a:buNone/>
-            </a:pPr>
-            <a:r>
-              <a:rPr lang="en-US" sz="2200" dirty="0">
-                <a:solidFill>
-                  <a:srgbClr val="000000"/>
-                </a:solidFill>
-              </a:rPr>
-              <a:t>📧</a:t>
-            </a:r>
-            <a:endParaRPr lang="en-US" sz="2200" dirty="0"/>
-          </a:p>
-        </p:txBody>
-      </p:sp>
-      <p:sp>
-        <p:nvSpPr>
-          <p:cNvPr id="26" name="Text 24"/>
-          <p:cNvSpPr/>
-          <p:nvPr/>
-        </p:nvSpPr>
-        <p:spPr>
-          <a:xfrm>
-            <a:off x="8961120" y="3063240"/>
-            <a:ext cx="2651760" cy="320040"/>
-          </a:xfrm>
-          <a:prstGeom prst="rect">
-            <a:avLst/>
-          </a:prstGeom>
-          <a:noFill/>
-          <a:ln/>
-        </p:spPr>
-        <p:txBody>
-          <a:bodyPr wrap="square" rtlCol="0" anchor="ctr"/>
-          <a:lstStyle/>
-          <a:p>
-            <a:pPr indent="0" marL="0">
-              <a:buNone/>
-            </a:pPr>
-            <a:r>
-              <a:rPr lang="en-US" sz="1100" b="1" dirty="0">
-                <a:solidFill>
-                  <a:srgbClr val="1D4ED8"/>
-                </a:solidFill>
-              </a:rPr>
-              <a:t>Notifications email</a:t>
-            </a:r>
-            <a:endParaRPr lang="en-US" sz="1100" dirty="0"/>
-          </a:p>
-        </p:txBody>
-      </p:sp>
-      <p:sp>
-        <p:nvSpPr>
-          <p:cNvPr id="27" name="Text 25"/>
-          <p:cNvSpPr/>
-          <p:nvPr/>
-        </p:nvSpPr>
-        <p:spPr>
-          <a:xfrm>
-            <a:off x="8961120" y="3383280"/>
-            <a:ext cx="2651760" cy="640080"/>
-          </a:xfrm>
-          <a:prstGeom prst="rect">
-            <a:avLst/>
-          </a:prstGeom>
-          <a:noFill/>
-          <a:ln/>
-        </p:spPr>
-        <p:txBody>
-          <a:bodyPr wrap="square" rtlCol="0" anchor="ctr"/>
-          <a:lstStyle/>
-          <a:p>
-            <a:pPr indent="0" marL="0">
-              <a:buNone/>
-            </a:pPr>
-            <a:r>
-              <a:rPr lang="en-US" sz="1000" dirty="0">
-                <a:solidFill>
-                  <a:srgbClr val="3730A3"/>
-                </a:solidFill>
-              </a:rPr>
-              <a:t>Alerte pour chaque action importante</a:t>
-            </a:r>
-            <a:endParaRPr lang="en-US" sz="1000" dirty="0"/>
-          </a:p>
-        </p:txBody>
-      </p:sp>
-      <p:sp>
-        <p:nvSpPr>
-          <p:cNvPr id="28" name="Shape 26"/>
-          <p:cNvSpPr/>
-          <p:nvPr/>
-        </p:nvSpPr>
-        <p:spPr>
-          <a:xfrm>
-            <a:off x="274320" y="4572000"/>
-            <a:ext cx="11247120" cy="1463040"/>
+          <p:cNvPr id="22" name="Shape 20"/>
+          <p:cNvSpPr/>
+          <p:nvPr/>
+        </p:nvSpPr>
+        <p:spPr>
+          <a:xfrm>
+            <a:off x="7406640" y="1188720"/>
+            <a:ext cx="4114800" cy="4846320"/>
           </a:xfrm>
           <a:prstGeom prst="roundRect">
             <a:avLst/>
@@ -6680,79 +6963,259 @@
       </p:sp>
       <p:sp>
         <p:nvSpPr>
+          <p:cNvPr id="23" name="Text 21"/>
+          <p:cNvSpPr/>
+          <p:nvPr/>
+        </p:nvSpPr>
+        <p:spPr>
+          <a:xfrm>
+            <a:off x="7589520" y="1280160"/>
+            <a:ext cx="3749040" cy="457200"/>
+          </a:xfrm>
+          <a:prstGeom prst="rect">
+            <a:avLst/>
+          </a:prstGeom>
+          <a:noFill/>
+          <a:ln/>
+        </p:spPr>
+        <p:txBody>
+          <a:bodyPr wrap="square" rtlCol="0" anchor="ctr"/>
+          <a:lstStyle/>
+          <a:p>
+            <a:pPr indent="0" marL="0">
+              <a:buNone/>
+            </a:pPr>
+            <a:r>
+              <a:rPr lang="en-US" sz="1300" b="1" dirty="0">
+                <a:solidFill>
+                  <a:srgbClr val="15803D"/>
+                </a:solidFill>
+              </a:rPr>
+              <a:t>Ce que le bureau maîtrise</a:t>
+            </a:r>
+            <a:endParaRPr lang="en-US" sz="1300" dirty="0"/>
+          </a:p>
+        </p:txBody>
+      </p:sp>
+      <p:sp>
+        <p:nvSpPr>
+          <p:cNvPr id="24" name="Text 22"/>
+          <p:cNvSpPr/>
+          <p:nvPr/>
+        </p:nvSpPr>
+        <p:spPr>
+          <a:xfrm>
+            <a:off x="7589520" y="1920240"/>
+            <a:ext cx="3749040" cy="548640"/>
+          </a:xfrm>
+          <a:prstGeom prst="rect">
+            <a:avLst/>
+          </a:prstGeom>
+          <a:noFill/>
+          <a:ln/>
+        </p:spPr>
+        <p:txBody>
+          <a:bodyPr wrap="square" rtlCol="0" anchor="ctr"/>
+          <a:lstStyle/>
+          <a:p>
+            <a:pPr indent="0" marL="0">
+              <a:buNone/>
+            </a:pPr>
+            <a:r>
+              <a:rPr lang="en-US" sz="1100" dirty="0">
+                <a:solidFill>
+                  <a:srgbClr val="166534"/>
+                </a:solidFill>
+              </a:rPr>
+              <a:t>✅  Barème configurable par tontine</a:t>
+            </a:r>
+            <a:endParaRPr lang="en-US" sz="1100" dirty="0"/>
+          </a:p>
+        </p:txBody>
+      </p:sp>
+      <p:sp>
+        <p:nvSpPr>
+          <p:cNvPr id="25" name="Text 23"/>
+          <p:cNvSpPr/>
+          <p:nvPr/>
+        </p:nvSpPr>
+        <p:spPr>
+          <a:xfrm>
+            <a:off x="7589520" y="2560320"/>
+            <a:ext cx="3749040" cy="548640"/>
+          </a:xfrm>
+          <a:prstGeom prst="rect">
+            <a:avLst/>
+          </a:prstGeom>
+          <a:noFill/>
+          <a:ln/>
+        </p:spPr>
+        <p:txBody>
+          <a:bodyPr wrap="square" rtlCol="0" anchor="ctr"/>
+          <a:lstStyle/>
+          <a:p>
+            <a:pPr indent="0" marL="0">
+              <a:buNone/>
+            </a:pPr>
+            <a:r>
+              <a:rPr lang="en-US" sz="1100" dirty="0">
+                <a:solidFill>
+                  <a:srgbClr val="166534"/>
+                </a:solidFill>
+              </a:rPr>
+              <a:t>✅  Préfinancement par la caisse</a:t>
+            </a:r>
+            <a:endParaRPr lang="en-US" sz="1100" dirty="0"/>
+          </a:p>
+        </p:txBody>
+      </p:sp>
+      <p:sp>
+        <p:nvSpPr>
+          <p:cNvPr id="26" name="Text 24"/>
+          <p:cNvSpPr/>
+          <p:nvPr/>
+        </p:nvSpPr>
+        <p:spPr>
+          <a:xfrm>
+            <a:off x="7589520" y="3200400"/>
+            <a:ext cx="3749040" cy="548640"/>
+          </a:xfrm>
+          <a:prstGeom prst="rect">
+            <a:avLst/>
+          </a:prstGeom>
+          <a:noFill/>
+          <a:ln/>
+        </p:spPr>
+        <p:txBody>
+          <a:bodyPr wrap="square" rtlCol="0" anchor="ctr"/>
+          <a:lstStyle/>
+          <a:p>
+            <a:pPr indent="0" marL="0">
+              <a:buNone/>
+            </a:pPr>
+            <a:r>
+              <a:rPr lang="en-US" sz="1100" dirty="0">
+                <a:solidFill>
+                  <a:srgbClr val="166534"/>
+                </a:solidFill>
+              </a:rPr>
+              <a:t>✅  Saisie bureau + accord du membre</a:t>
+            </a:r>
+            <a:endParaRPr lang="en-US" sz="1100" dirty="0"/>
+          </a:p>
+        </p:txBody>
+      </p:sp>
+      <p:sp>
+        <p:nvSpPr>
+          <p:cNvPr id="27" name="Text 25"/>
+          <p:cNvSpPr/>
+          <p:nvPr/>
+        </p:nvSpPr>
+        <p:spPr>
+          <a:xfrm>
+            <a:off x="7589520" y="3840480"/>
+            <a:ext cx="3749040" cy="548640"/>
+          </a:xfrm>
+          <a:prstGeom prst="rect">
+            <a:avLst/>
+          </a:prstGeom>
+          <a:noFill/>
+          <a:ln/>
+        </p:spPr>
+        <p:txBody>
+          <a:bodyPr wrap="square" rtlCol="0" anchor="ctr"/>
+          <a:lstStyle/>
+          <a:p>
+            <a:pPr indent="0" marL="0">
+              <a:buNone/>
+            </a:pPr>
+            <a:r>
+              <a:rPr lang="en-US" sz="1100" dirty="0">
+                <a:solidFill>
+                  <a:srgbClr val="166534"/>
+                </a:solidFill>
+              </a:rPr>
+              <a:t>✅  Variantes père / mère</a:t>
+            </a:r>
+            <a:endParaRPr lang="en-US" sz="1100" dirty="0"/>
+          </a:p>
+        </p:txBody>
+      </p:sp>
+      <p:sp>
+        <p:nvSpPr>
+          <p:cNvPr id="28" name="Text 26"/>
+          <p:cNvSpPr/>
+          <p:nvPr/>
+        </p:nvSpPr>
+        <p:spPr>
+          <a:xfrm>
+            <a:off x="7589520" y="4480560"/>
+            <a:ext cx="3749040" cy="548640"/>
+          </a:xfrm>
+          <a:prstGeom prst="rect">
+            <a:avLst/>
+          </a:prstGeom>
+          <a:noFill/>
+          <a:ln/>
+        </p:spPr>
+        <p:txBody>
+          <a:bodyPr wrap="square" rtlCol="0" anchor="ctr"/>
+          <a:lstStyle/>
+          <a:p>
+            <a:pPr indent="0" marL="0">
+              <a:buNone/>
+            </a:pPr>
+            <a:r>
+              <a:rPr lang="en-US" sz="1100" dirty="0">
+                <a:solidFill>
+                  <a:srgbClr val="166534"/>
+                </a:solidFill>
+              </a:rPr>
+              <a:t>✅  Suivi collecte et trésorerie</a:t>
+            </a:r>
+            <a:endParaRPr lang="en-US" sz="1100" dirty="0"/>
+          </a:p>
+        </p:txBody>
+      </p:sp>
+      <p:sp>
+        <p:nvSpPr>
           <p:cNvPr id="29" name="Text 27"/>
           <p:cNvSpPr/>
           <p:nvPr/>
         </p:nvSpPr>
         <p:spPr>
           <a:xfrm>
-            <a:off x="548640" y="4663440"/>
-            <a:ext cx="2286000" cy="365760"/>
-          </a:xfrm>
-          <a:prstGeom prst="rect">
-            <a:avLst/>
-          </a:prstGeom>
-          <a:noFill/>
-          <a:ln/>
-        </p:spPr>
-        <p:txBody>
-          <a:bodyPr wrap="square" rtlCol="0" anchor="ctr"/>
-          <a:lstStyle/>
-          <a:p>
-            <a:pPr indent="0" marL="0">
-              <a:buNone/>
-            </a:pPr>
-            <a:r>
-              <a:rPr lang="en-US" sz="1200" b="1" dirty="0">
-                <a:solidFill>
-                  <a:srgbClr val="15803D"/>
-                </a:solidFill>
-              </a:rPr>
-              <a:t>Multi-tontine :</a:t>
-            </a:r>
-            <a:endParaRPr lang="en-US" sz="1200" dirty="0"/>
+            <a:off x="7589520" y="5120640"/>
+            <a:ext cx="3749040" cy="548640"/>
+          </a:xfrm>
+          <a:prstGeom prst="rect">
+            <a:avLst/>
+          </a:prstGeom>
+          <a:noFill/>
+          <a:ln/>
+        </p:spPr>
+        <p:txBody>
+          <a:bodyPr wrap="square" rtlCol="0" anchor="ctr"/>
+          <a:lstStyle/>
+          <a:p>
+            <a:pPr indent="0" marL="0">
+              <a:buNone/>
+            </a:pPr>
+            <a:r>
+              <a:rPr lang="en-US" sz="1100" dirty="0">
+                <a:solidFill>
+                  <a:srgbClr val="166534"/>
+                </a:solidFill>
+              </a:rPr>
+              <a:t>✅  Fonds d'aide mois par mois</a:t>
+            </a:r>
+            <a:endParaRPr lang="en-US" sz="1100" dirty="0"/>
           </a:p>
         </p:txBody>
       </p:sp>
       <p:sp>
         <p:nvSpPr>
           <p:cNvPr id="30" name="Text 28"/>
-          <p:cNvSpPr/>
-          <p:nvPr/>
-        </p:nvSpPr>
-        <p:spPr>
-          <a:xfrm>
-            <a:off x="548640" y="5029200"/>
-            <a:ext cx="10972800" cy="731520"/>
-          </a:xfrm>
-          <a:prstGeom prst="rect">
-            <a:avLst/>
-          </a:prstGeom>
-          <a:noFill/>
-          <a:ln/>
-        </p:spPr>
-        <p:txBody>
-          <a:bodyPr wrap="square" rtlCol="0" anchor="ctr"/>
-          <a:lstStyle/>
-          <a:p>
-            <a:pPr indent="0" marL="0">
-              <a:buNone/>
-            </a:pPr>
-            <a:r>
-              <a:rPr lang="en-US" sz="1100" dirty="0">
-                <a:solidFill>
-                  <a:srgbClr val="166534"/>
-                </a:solidFill>
-              </a:rPr>
-              <a:t>Un même opérateur peut gérer plusieurs tontines avec des comptes distincts. Chaque membre ne voit que les données de SA tontine. Isolation totale garantie.</a:t>
-            </a:r>
-            <a:endParaRPr lang="en-US" sz="1100" dirty="0"/>
-          </a:p>
-        </p:txBody>
-      </p:sp>
-      <p:sp>
-        <p:nvSpPr>
-          <p:cNvPr id="31" name="Text 29"/>
           <p:cNvSpPr/>
           <p:nvPr/>
         </p:nvSpPr>
@@ -6780,7 +7243,7 @@
                   <a:srgbClr val="94A3B8"/>
                 </a:solidFill>
               </a:rPr>
-              <a:t>TontinePro v1.0  ·  JumpyTech  ·  © 2026</a:t>
+              <a:t>TontinePro v1.1  ·  JumpyTech  ·  © 2026</a:t>
             </a:r>
             <a:endParaRPr lang="en-US" sz="800" dirty="0"/>
           </a:p>
@@ -6788,7 +7251,7 @@
       </p:sp>
       <p:sp>
         <p:nvSpPr>
-          <p:cNvPr id="32" name="Text 30"/>
+          <p:cNvPr id="31" name="Text 29"/>
           <p:cNvSpPr/>
           <p:nvPr/>
         </p:nvSpPr>
@@ -6833,6 +7296,1077 @@
 <file path=ppt/slides/slide7.xml><?xml version="1.0" encoding="utf-8"?>
 <p:sld xmlns:a="http://schemas.openxmlformats.org/drawingml/2006/main" xmlns:r="http://schemas.openxmlformats.org/officeDocument/2006/relationships" xmlns:p="http://schemas.openxmlformats.org/presentationml/2006/main">
   <p:cSld name="Slide 7">
+    <p:bg>
+      <p:bgPr>
+        <a:solidFill>
+          <a:srgbClr val="FFFFFF"/>
+        </a:solidFill>
+      </p:bgPr>
+    </p:bg>
+    <p:spTree>
+      <p:nvGrpSpPr>
+        <p:cNvPr id="1" name=""/>
+        <p:cNvGrpSpPr/>
+        <p:nvPr/>
+      </p:nvGrpSpPr>
+      <p:grpSpPr>
+        <a:xfrm>
+          <a:off x="0" y="0"/>
+          <a:ext cx="0" cy="0"/>
+          <a:chOff x="0" y="0"/>
+          <a:chExt cx="0" cy="0"/>
+        </a:xfrm>
+      </p:grpSpPr>
+      <p:sp>
+        <p:nvSpPr>
+          <p:cNvPr id="2" name="Text 0"/>
+          <p:cNvSpPr/>
+          <p:nvPr/>
+        </p:nvSpPr>
+        <p:spPr>
+          <a:xfrm>
+            <a:off x="457200" y="182880"/>
+            <a:ext cx="10972800" cy="365760"/>
+          </a:xfrm>
+          <a:prstGeom prst="rect">
+            <a:avLst/>
+          </a:prstGeom>
+          <a:noFill/>
+          <a:ln/>
+        </p:spPr>
+        <p:txBody>
+          <a:bodyPr wrap="square" rtlCol="0" anchor="ctr"/>
+          <a:lstStyle/>
+          <a:p>
+            <a:pPr indent="0" marL="0">
+              <a:buNone/>
+            </a:pPr>
+            <a:r>
+              <a:rPr lang="en-US" sz="1100" b="1" spc="300" kern="0" dirty="0">
+                <a:solidFill>
+                  <a:srgbClr val="4F46E5"/>
+                </a:solidFill>
+              </a:rPr>
+              <a:t>SÉCURITÉ &amp; MULTI-TONTINE</a:t>
+            </a:r>
+            <a:endParaRPr lang="en-US" sz="1100" dirty="0"/>
+          </a:p>
+        </p:txBody>
+      </p:sp>
+      <p:sp>
+        <p:nvSpPr>
+          <p:cNvPr id="3" name="Text 1"/>
+          <p:cNvSpPr/>
+          <p:nvPr/>
+        </p:nvSpPr>
+        <p:spPr>
+          <a:xfrm>
+            <a:off x="457200" y="548640"/>
+            <a:ext cx="10972800" cy="457200"/>
+          </a:xfrm>
+          <a:prstGeom prst="rect">
+            <a:avLst/>
+          </a:prstGeom>
+          <a:noFill/>
+          <a:ln/>
+        </p:spPr>
+        <p:txBody>
+          <a:bodyPr wrap="square" rtlCol="0" anchor="ctr"/>
+          <a:lstStyle/>
+          <a:p>
+            <a:pPr indent="0" marL="0">
+              <a:buNone/>
+            </a:pPr>
+            <a:r>
+              <a:rPr lang="en-US" sz="2200" b="1" dirty="0">
+                <a:solidFill>
+                  <a:srgbClr val="1E293B"/>
+                </a:solidFill>
+              </a:rPr>
+              <a:t>Vos données protégées, vos tontines bien séparées</a:t>
+            </a:r>
+            <a:endParaRPr lang="en-US" sz="2200" dirty="0"/>
+          </a:p>
+        </p:txBody>
+      </p:sp>
+      <p:sp>
+        <p:nvSpPr>
+          <p:cNvPr id="4" name="Shape 2"/>
+          <p:cNvSpPr/>
+          <p:nvPr/>
+        </p:nvSpPr>
+        <p:spPr>
+          <a:xfrm>
+            <a:off x="274320" y="1280160"/>
+            <a:ext cx="3657600" cy="1371600"/>
+          </a:xfrm>
+          <a:prstGeom prst="roundRect">
+            <a:avLst/>
+          </a:prstGeom>
+          <a:solidFill>
+            <a:srgbClr val="EFF6FF"/>
+          </a:solidFill>
+          <a:ln w="12700">
+            <a:solidFill>
+              <a:srgbClr val="BFDBFE"/>
+            </a:solidFill>
+            <a:prstDash val="solid"/>
+          </a:ln>
+        </p:spPr>
+      </p:sp>
+      <p:sp>
+        <p:nvSpPr>
+          <p:cNvPr id="5" name="Text 3"/>
+          <p:cNvSpPr/>
+          <p:nvPr/>
+        </p:nvSpPr>
+        <p:spPr>
+          <a:xfrm>
+            <a:off x="457200" y="1417320"/>
+            <a:ext cx="640080" cy="640080"/>
+          </a:xfrm>
+          <a:prstGeom prst="rect">
+            <a:avLst/>
+          </a:prstGeom>
+          <a:noFill/>
+          <a:ln/>
+        </p:spPr>
+        <p:txBody>
+          <a:bodyPr wrap="square" rtlCol="0" anchor="ctr"/>
+          <a:lstStyle/>
+          <a:p>
+            <a:pPr indent="0" marL="0">
+              <a:buNone/>
+            </a:pPr>
+            <a:r>
+              <a:rPr lang="en-US" sz="2200" dirty="0">
+                <a:solidFill>
+                  <a:srgbClr val="000000"/>
+                </a:solidFill>
+              </a:rPr>
+              <a:t>🔐</a:t>
+            </a:r>
+            <a:endParaRPr lang="en-US" sz="2200" dirty="0"/>
+          </a:p>
+        </p:txBody>
+      </p:sp>
+      <p:sp>
+        <p:nvSpPr>
+          <p:cNvPr id="6" name="Text 4"/>
+          <p:cNvSpPr/>
+          <p:nvPr/>
+        </p:nvSpPr>
+        <p:spPr>
+          <a:xfrm>
+            <a:off x="1097280" y="1417320"/>
+            <a:ext cx="2651760" cy="320040"/>
+          </a:xfrm>
+          <a:prstGeom prst="rect">
+            <a:avLst/>
+          </a:prstGeom>
+          <a:noFill/>
+          <a:ln/>
+        </p:spPr>
+        <p:txBody>
+          <a:bodyPr wrap="square" rtlCol="0" anchor="ctr"/>
+          <a:lstStyle/>
+          <a:p>
+            <a:pPr indent="0" marL="0">
+              <a:buNone/>
+            </a:pPr>
+            <a:r>
+              <a:rPr lang="en-US" sz="1100" b="1" dirty="0">
+                <a:solidFill>
+                  <a:srgbClr val="1D4ED8"/>
+                </a:solidFill>
+              </a:rPr>
+              <a:t>Double authentification</a:t>
+            </a:r>
+            <a:endParaRPr lang="en-US" sz="1100" dirty="0"/>
+          </a:p>
+        </p:txBody>
+      </p:sp>
+      <p:sp>
+        <p:nvSpPr>
+          <p:cNvPr id="7" name="Text 5"/>
+          <p:cNvSpPr/>
+          <p:nvPr/>
+        </p:nvSpPr>
+        <p:spPr>
+          <a:xfrm>
+            <a:off x="1097280" y="1737360"/>
+            <a:ext cx="2651760" cy="640080"/>
+          </a:xfrm>
+          <a:prstGeom prst="rect">
+            <a:avLst/>
+          </a:prstGeom>
+          <a:noFill/>
+          <a:ln/>
+        </p:spPr>
+        <p:txBody>
+          <a:bodyPr wrap="square" rtlCol="0" anchor="ctr"/>
+          <a:lstStyle/>
+          <a:p>
+            <a:pPr indent="0" marL="0">
+              <a:buNone/>
+            </a:pPr>
+            <a:r>
+              <a:rPr lang="en-US" sz="1000" dirty="0">
+                <a:solidFill>
+                  <a:srgbClr val="3730A3"/>
+                </a:solidFill>
+              </a:rPr>
+              <a:t>2FA avec Google Authenticator ou Authy</a:t>
+            </a:r>
+            <a:endParaRPr lang="en-US" sz="1000" dirty="0"/>
+          </a:p>
+        </p:txBody>
+      </p:sp>
+      <p:sp>
+        <p:nvSpPr>
+          <p:cNvPr id="8" name="Shape 6"/>
+          <p:cNvSpPr/>
+          <p:nvPr/>
+        </p:nvSpPr>
+        <p:spPr>
+          <a:xfrm>
+            <a:off x="4206240" y="1280160"/>
+            <a:ext cx="3657600" cy="1371600"/>
+          </a:xfrm>
+          <a:prstGeom prst="roundRect">
+            <a:avLst/>
+          </a:prstGeom>
+          <a:solidFill>
+            <a:srgbClr val="EFF6FF"/>
+          </a:solidFill>
+          <a:ln w="12700">
+            <a:solidFill>
+              <a:srgbClr val="BFDBFE"/>
+            </a:solidFill>
+            <a:prstDash val="solid"/>
+          </a:ln>
+        </p:spPr>
+      </p:sp>
+      <p:sp>
+        <p:nvSpPr>
+          <p:cNvPr id="9" name="Text 7"/>
+          <p:cNvSpPr/>
+          <p:nvPr/>
+        </p:nvSpPr>
+        <p:spPr>
+          <a:xfrm>
+            <a:off x="4389120" y="1417320"/>
+            <a:ext cx="640080" cy="640080"/>
+          </a:xfrm>
+          <a:prstGeom prst="rect">
+            <a:avLst/>
+          </a:prstGeom>
+          <a:noFill/>
+          <a:ln/>
+        </p:spPr>
+        <p:txBody>
+          <a:bodyPr wrap="square" rtlCol="0" anchor="ctr"/>
+          <a:lstStyle/>
+          <a:p>
+            <a:pPr indent="0" marL="0">
+              <a:buNone/>
+            </a:pPr>
+            <a:r>
+              <a:rPr lang="en-US" sz="2200" dirty="0">
+                <a:solidFill>
+                  <a:srgbClr val="000000"/>
+                </a:solidFill>
+              </a:rPr>
+              <a:t>🔒</a:t>
+            </a:r>
+            <a:endParaRPr lang="en-US" sz="2200" dirty="0"/>
+          </a:p>
+        </p:txBody>
+      </p:sp>
+      <p:sp>
+        <p:nvSpPr>
+          <p:cNvPr id="10" name="Text 8"/>
+          <p:cNvSpPr/>
+          <p:nvPr/>
+        </p:nvSpPr>
+        <p:spPr>
+          <a:xfrm>
+            <a:off x="5029200" y="1417320"/>
+            <a:ext cx="2651760" cy="320040"/>
+          </a:xfrm>
+          <a:prstGeom prst="rect">
+            <a:avLst/>
+          </a:prstGeom>
+          <a:noFill/>
+          <a:ln/>
+        </p:spPr>
+        <p:txBody>
+          <a:bodyPr wrap="square" rtlCol="0" anchor="ctr"/>
+          <a:lstStyle/>
+          <a:p>
+            <a:pPr indent="0" marL="0">
+              <a:buNone/>
+            </a:pPr>
+            <a:r>
+              <a:rPr lang="en-US" sz="1100" b="1" dirty="0">
+                <a:solidFill>
+                  <a:srgbClr val="1D4ED8"/>
+                </a:solidFill>
+              </a:rPr>
+              <a:t>Tokens JWT sécurisés</a:t>
+            </a:r>
+            <a:endParaRPr lang="en-US" sz="1100" dirty="0"/>
+          </a:p>
+        </p:txBody>
+      </p:sp>
+      <p:sp>
+        <p:nvSpPr>
+          <p:cNvPr id="11" name="Text 9"/>
+          <p:cNvSpPr/>
+          <p:nvPr/>
+        </p:nvSpPr>
+        <p:spPr>
+          <a:xfrm>
+            <a:off x="5029200" y="1737360"/>
+            <a:ext cx="2651760" cy="640080"/>
+          </a:xfrm>
+          <a:prstGeom prst="rect">
+            <a:avLst/>
+          </a:prstGeom>
+          <a:noFill/>
+          <a:ln/>
+        </p:spPr>
+        <p:txBody>
+          <a:bodyPr wrap="square" rtlCol="0" anchor="ctr"/>
+          <a:lstStyle/>
+          <a:p>
+            <a:pPr indent="0" marL="0">
+              <a:buNone/>
+            </a:pPr>
+            <a:r>
+              <a:rPr lang="en-US" sz="1000" dirty="0">
+                <a:solidFill>
+                  <a:srgbClr val="3730A3"/>
+                </a:solidFill>
+              </a:rPr>
+              <a:t>Sessions à durée limitée, déconnexion immédiate</a:t>
+            </a:r>
+            <a:endParaRPr lang="en-US" sz="1000" dirty="0"/>
+          </a:p>
+        </p:txBody>
+      </p:sp>
+      <p:sp>
+        <p:nvSpPr>
+          <p:cNvPr id="12" name="Shape 10"/>
+          <p:cNvSpPr/>
+          <p:nvPr/>
+        </p:nvSpPr>
+        <p:spPr>
+          <a:xfrm>
+            <a:off x="8138160" y="1280160"/>
+            <a:ext cx="3657600" cy="1371600"/>
+          </a:xfrm>
+          <a:prstGeom prst="roundRect">
+            <a:avLst/>
+          </a:prstGeom>
+          <a:solidFill>
+            <a:srgbClr val="EFF6FF"/>
+          </a:solidFill>
+          <a:ln w="12700">
+            <a:solidFill>
+              <a:srgbClr val="BFDBFE"/>
+            </a:solidFill>
+            <a:prstDash val="solid"/>
+          </a:ln>
+        </p:spPr>
+      </p:sp>
+      <p:sp>
+        <p:nvSpPr>
+          <p:cNvPr id="13" name="Text 11"/>
+          <p:cNvSpPr/>
+          <p:nvPr/>
+        </p:nvSpPr>
+        <p:spPr>
+          <a:xfrm>
+            <a:off x="8321040" y="1417320"/>
+            <a:ext cx="640080" cy="640080"/>
+          </a:xfrm>
+          <a:prstGeom prst="rect">
+            <a:avLst/>
+          </a:prstGeom>
+          <a:noFill/>
+          <a:ln/>
+        </p:spPr>
+        <p:txBody>
+          <a:bodyPr wrap="square" rtlCol="0" anchor="ctr"/>
+          <a:lstStyle/>
+          <a:p>
+            <a:pPr indent="0" marL="0">
+              <a:buNone/>
+            </a:pPr>
+            <a:r>
+              <a:rPr lang="en-US" sz="2200" dirty="0">
+                <a:solidFill>
+                  <a:srgbClr val="000000"/>
+                </a:solidFill>
+              </a:rPr>
+              <a:t>🌐</a:t>
+            </a:r>
+            <a:endParaRPr lang="en-US" sz="2200" dirty="0"/>
+          </a:p>
+        </p:txBody>
+      </p:sp>
+      <p:sp>
+        <p:nvSpPr>
+          <p:cNvPr id="14" name="Text 12"/>
+          <p:cNvSpPr/>
+          <p:nvPr/>
+        </p:nvSpPr>
+        <p:spPr>
+          <a:xfrm>
+            <a:off x="8961120" y="1417320"/>
+            <a:ext cx="2651760" cy="320040"/>
+          </a:xfrm>
+          <a:prstGeom prst="rect">
+            <a:avLst/>
+          </a:prstGeom>
+          <a:noFill/>
+          <a:ln/>
+        </p:spPr>
+        <p:txBody>
+          <a:bodyPr wrap="square" rtlCol="0" anchor="ctr"/>
+          <a:lstStyle/>
+          <a:p>
+            <a:pPr indent="0" marL="0">
+              <a:buNone/>
+            </a:pPr>
+            <a:r>
+              <a:rPr lang="en-US" sz="1100" b="1" dirty="0">
+                <a:solidFill>
+                  <a:srgbClr val="1D4ED8"/>
+                </a:solidFill>
+              </a:rPr>
+              <a:t>HTTPS + CORS strict</a:t>
+            </a:r>
+            <a:endParaRPr lang="en-US" sz="1100" dirty="0"/>
+          </a:p>
+        </p:txBody>
+      </p:sp>
+      <p:sp>
+        <p:nvSpPr>
+          <p:cNvPr id="15" name="Text 13"/>
+          <p:cNvSpPr/>
+          <p:nvPr/>
+        </p:nvSpPr>
+        <p:spPr>
+          <a:xfrm>
+            <a:off x="8961120" y="1737360"/>
+            <a:ext cx="2651760" cy="640080"/>
+          </a:xfrm>
+          <a:prstGeom prst="rect">
+            <a:avLst/>
+          </a:prstGeom>
+          <a:noFill/>
+          <a:ln/>
+        </p:spPr>
+        <p:txBody>
+          <a:bodyPr wrap="square" rtlCol="0" anchor="ctr"/>
+          <a:lstStyle/>
+          <a:p>
+            <a:pPr indent="0" marL="0">
+              <a:buNone/>
+            </a:pPr>
+            <a:r>
+              <a:rPr lang="en-US" sz="1000" dirty="0">
+                <a:solidFill>
+                  <a:srgbClr val="3730A3"/>
+                </a:solidFill>
+              </a:rPr>
+              <a:t>Communication chiffrée TLS</a:t>
+            </a:r>
+            <a:endParaRPr lang="en-US" sz="1000" dirty="0"/>
+          </a:p>
+        </p:txBody>
+      </p:sp>
+      <p:sp>
+        <p:nvSpPr>
+          <p:cNvPr id="16" name="Shape 14"/>
+          <p:cNvSpPr/>
+          <p:nvPr/>
+        </p:nvSpPr>
+        <p:spPr>
+          <a:xfrm>
+            <a:off x="274320" y="2926080"/>
+            <a:ext cx="3657600" cy="1371600"/>
+          </a:xfrm>
+          <a:prstGeom prst="roundRect">
+            <a:avLst/>
+          </a:prstGeom>
+          <a:solidFill>
+            <a:srgbClr val="EFF6FF"/>
+          </a:solidFill>
+          <a:ln w="12700">
+            <a:solidFill>
+              <a:srgbClr val="BFDBFE"/>
+            </a:solidFill>
+            <a:prstDash val="solid"/>
+          </a:ln>
+        </p:spPr>
+      </p:sp>
+      <p:sp>
+        <p:nvSpPr>
+          <p:cNvPr id="17" name="Text 15"/>
+          <p:cNvSpPr/>
+          <p:nvPr/>
+        </p:nvSpPr>
+        <p:spPr>
+          <a:xfrm>
+            <a:off x="457200" y="3063240"/>
+            <a:ext cx="640080" cy="640080"/>
+          </a:xfrm>
+          <a:prstGeom prst="rect">
+            <a:avLst/>
+          </a:prstGeom>
+          <a:noFill/>
+          <a:ln/>
+        </p:spPr>
+        <p:txBody>
+          <a:bodyPr wrap="square" rtlCol="0" anchor="ctr"/>
+          <a:lstStyle/>
+          <a:p>
+            <a:pPr indent="0" marL="0">
+              <a:buNone/>
+            </a:pPr>
+            <a:r>
+              <a:rPr lang="en-US" sz="2200" dirty="0">
+                <a:solidFill>
+                  <a:srgbClr val="000000"/>
+                </a:solidFill>
+              </a:rPr>
+              <a:t>🏛️</a:t>
+            </a:r>
+            <a:endParaRPr lang="en-US" sz="2200" dirty="0"/>
+          </a:p>
+        </p:txBody>
+      </p:sp>
+      <p:sp>
+        <p:nvSpPr>
+          <p:cNvPr id="18" name="Text 16"/>
+          <p:cNvSpPr/>
+          <p:nvPr/>
+        </p:nvSpPr>
+        <p:spPr>
+          <a:xfrm>
+            <a:off x="1097280" y="3063240"/>
+            <a:ext cx="2651760" cy="320040"/>
+          </a:xfrm>
+          <a:prstGeom prst="rect">
+            <a:avLst/>
+          </a:prstGeom>
+          <a:noFill/>
+          <a:ln/>
+        </p:spPr>
+        <p:txBody>
+          <a:bodyPr wrap="square" rtlCol="0" anchor="ctr"/>
+          <a:lstStyle/>
+          <a:p>
+            <a:pPr indent="0" marL="0">
+              <a:buNone/>
+            </a:pPr>
+            <a:r>
+              <a:rPr lang="en-US" sz="1100" b="1" dirty="0">
+                <a:solidFill>
+                  <a:srgbClr val="1D4ED8"/>
+                </a:solidFill>
+              </a:rPr>
+              <a:t>Rôles et permissions</a:t>
+            </a:r>
+            <a:endParaRPr lang="en-US" sz="1100" dirty="0"/>
+          </a:p>
+        </p:txBody>
+      </p:sp>
+      <p:sp>
+        <p:nvSpPr>
+          <p:cNvPr id="19" name="Text 17"/>
+          <p:cNvSpPr/>
+          <p:nvPr/>
+        </p:nvSpPr>
+        <p:spPr>
+          <a:xfrm>
+            <a:off x="1097280" y="3383280"/>
+            <a:ext cx="2651760" cy="640080"/>
+          </a:xfrm>
+          <a:prstGeom prst="rect">
+            <a:avLst/>
+          </a:prstGeom>
+          <a:noFill/>
+          <a:ln/>
+        </p:spPr>
+        <p:txBody>
+          <a:bodyPr wrap="square" rtlCol="0" anchor="ctr"/>
+          <a:lstStyle/>
+          <a:p>
+            <a:pPr indent="0" marL="0">
+              <a:buNone/>
+            </a:pPr>
+            <a:r>
+              <a:rPr lang="en-US" sz="1000" dirty="0">
+                <a:solidFill>
+                  <a:srgbClr val="3730A3"/>
+                </a:solidFill>
+              </a:rPr>
+              <a:t>SUPER_ADMIN · Président · Secrétaire · Membre</a:t>
+            </a:r>
+            <a:endParaRPr lang="en-US" sz="1000" dirty="0"/>
+          </a:p>
+        </p:txBody>
+      </p:sp>
+      <p:sp>
+        <p:nvSpPr>
+          <p:cNvPr id="20" name="Shape 18"/>
+          <p:cNvSpPr/>
+          <p:nvPr/>
+        </p:nvSpPr>
+        <p:spPr>
+          <a:xfrm>
+            <a:off x="4206240" y="2926080"/>
+            <a:ext cx="3657600" cy="1371600"/>
+          </a:xfrm>
+          <a:prstGeom prst="roundRect">
+            <a:avLst/>
+          </a:prstGeom>
+          <a:solidFill>
+            <a:srgbClr val="EFF6FF"/>
+          </a:solidFill>
+          <a:ln w="12700">
+            <a:solidFill>
+              <a:srgbClr val="BFDBFE"/>
+            </a:solidFill>
+            <a:prstDash val="solid"/>
+          </a:ln>
+        </p:spPr>
+      </p:sp>
+      <p:sp>
+        <p:nvSpPr>
+          <p:cNvPr id="21" name="Text 19"/>
+          <p:cNvSpPr/>
+          <p:nvPr/>
+        </p:nvSpPr>
+        <p:spPr>
+          <a:xfrm>
+            <a:off x="4389120" y="3063240"/>
+            <a:ext cx="640080" cy="640080"/>
+          </a:xfrm>
+          <a:prstGeom prst="rect">
+            <a:avLst/>
+          </a:prstGeom>
+          <a:noFill/>
+          <a:ln/>
+        </p:spPr>
+        <p:txBody>
+          <a:bodyPr wrap="square" rtlCol="0" anchor="ctr"/>
+          <a:lstStyle/>
+          <a:p>
+            <a:pPr indent="0" marL="0">
+              <a:buNone/>
+            </a:pPr>
+            <a:r>
+              <a:rPr lang="en-US" sz="2200" dirty="0">
+                <a:solidFill>
+                  <a:srgbClr val="000000"/>
+                </a:solidFill>
+              </a:rPr>
+              <a:t>💾</a:t>
+            </a:r>
+            <a:endParaRPr lang="en-US" sz="2200" dirty="0"/>
+          </a:p>
+        </p:txBody>
+      </p:sp>
+      <p:sp>
+        <p:nvSpPr>
+          <p:cNvPr id="22" name="Text 20"/>
+          <p:cNvSpPr/>
+          <p:nvPr/>
+        </p:nvSpPr>
+        <p:spPr>
+          <a:xfrm>
+            <a:off x="5029200" y="3063240"/>
+            <a:ext cx="2651760" cy="320040"/>
+          </a:xfrm>
+          <a:prstGeom prst="rect">
+            <a:avLst/>
+          </a:prstGeom>
+          <a:noFill/>
+          <a:ln/>
+        </p:spPr>
+        <p:txBody>
+          <a:bodyPr wrap="square" rtlCol="0" anchor="ctr"/>
+          <a:lstStyle/>
+          <a:p>
+            <a:pPr indent="0" marL="0">
+              <a:buNone/>
+            </a:pPr>
+            <a:r>
+              <a:rPr lang="en-US" sz="1100" b="1" dirty="0">
+                <a:solidFill>
+                  <a:srgbClr val="1D4ED8"/>
+                </a:solidFill>
+              </a:rPr>
+              <a:t>Hébergement local</a:t>
+            </a:r>
+            <a:endParaRPr lang="en-US" sz="1100" dirty="0"/>
+          </a:p>
+        </p:txBody>
+      </p:sp>
+      <p:sp>
+        <p:nvSpPr>
+          <p:cNvPr id="23" name="Text 21"/>
+          <p:cNvSpPr/>
+          <p:nvPr/>
+        </p:nvSpPr>
+        <p:spPr>
+          <a:xfrm>
+            <a:off x="5029200" y="3383280"/>
+            <a:ext cx="2651760" cy="640080"/>
+          </a:xfrm>
+          <a:prstGeom prst="rect">
+            <a:avLst/>
+          </a:prstGeom>
+          <a:noFill/>
+          <a:ln/>
+        </p:spPr>
+        <p:txBody>
+          <a:bodyPr wrap="square" rtlCol="0" anchor="ctr"/>
+          <a:lstStyle/>
+          <a:p>
+            <a:pPr indent="0" marL="0">
+              <a:buNone/>
+            </a:pPr>
+            <a:r>
+              <a:rPr lang="en-US" sz="1000" dirty="0">
+                <a:solidFill>
+                  <a:srgbClr val="3730A3"/>
+                </a:solidFill>
+              </a:rPr>
+              <a:t>Vos données ne transitent pas par des tiers</a:t>
+            </a:r>
+            <a:endParaRPr lang="en-US" sz="1000" dirty="0"/>
+          </a:p>
+        </p:txBody>
+      </p:sp>
+      <p:sp>
+        <p:nvSpPr>
+          <p:cNvPr id="24" name="Shape 22"/>
+          <p:cNvSpPr/>
+          <p:nvPr/>
+        </p:nvSpPr>
+        <p:spPr>
+          <a:xfrm>
+            <a:off x="8138160" y="2926080"/>
+            <a:ext cx="3657600" cy="1371600"/>
+          </a:xfrm>
+          <a:prstGeom prst="roundRect">
+            <a:avLst/>
+          </a:prstGeom>
+          <a:solidFill>
+            <a:srgbClr val="EFF6FF"/>
+          </a:solidFill>
+          <a:ln w="12700">
+            <a:solidFill>
+              <a:srgbClr val="BFDBFE"/>
+            </a:solidFill>
+            <a:prstDash val="solid"/>
+          </a:ln>
+        </p:spPr>
+      </p:sp>
+      <p:sp>
+        <p:nvSpPr>
+          <p:cNvPr id="25" name="Text 23"/>
+          <p:cNvSpPr/>
+          <p:nvPr/>
+        </p:nvSpPr>
+        <p:spPr>
+          <a:xfrm>
+            <a:off x="8321040" y="3063240"/>
+            <a:ext cx="640080" cy="640080"/>
+          </a:xfrm>
+          <a:prstGeom prst="rect">
+            <a:avLst/>
+          </a:prstGeom>
+          <a:noFill/>
+          <a:ln/>
+        </p:spPr>
+        <p:txBody>
+          <a:bodyPr wrap="square" rtlCol="0" anchor="ctr"/>
+          <a:lstStyle/>
+          <a:p>
+            <a:pPr indent="0" marL="0">
+              <a:buNone/>
+            </a:pPr>
+            <a:r>
+              <a:rPr lang="en-US" sz="2200" dirty="0">
+                <a:solidFill>
+                  <a:srgbClr val="000000"/>
+                </a:solidFill>
+              </a:rPr>
+              <a:t>📧</a:t>
+            </a:r>
+            <a:endParaRPr lang="en-US" sz="2200" dirty="0"/>
+          </a:p>
+        </p:txBody>
+      </p:sp>
+      <p:sp>
+        <p:nvSpPr>
+          <p:cNvPr id="26" name="Text 24"/>
+          <p:cNvSpPr/>
+          <p:nvPr/>
+        </p:nvSpPr>
+        <p:spPr>
+          <a:xfrm>
+            <a:off x="8961120" y="3063240"/>
+            <a:ext cx="2651760" cy="320040"/>
+          </a:xfrm>
+          <a:prstGeom prst="rect">
+            <a:avLst/>
+          </a:prstGeom>
+          <a:noFill/>
+          <a:ln/>
+        </p:spPr>
+        <p:txBody>
+          <a:bodyPr wrap="square" rtlCol="0" anchor="ctr"/>
+          <a:lstStyle/>
+          <a:p>
+            <a:pPr indent="0" marL="0">
+              <a:buNone/>
+            </a:pPr>
+            <a:r>
+              <a:rPr lang="en-US" sz="1100" b="1" dirty="0">
+                <a:solidFill>
+                  <a:srgbClr val="1D4ED8"/>
+                </a:solidFill>
+              </a:rPr>
+              <a:t>Notifications email</a:t>
+            </a:r>
+            <a:endParaRPr lang="en-US" sz="1100" dirty="0"/>
+          </a:p>
+        </p:txBody>
+      </p:sp>
+      <p:sp>
+        <p:nvSpPr>
+          <p:cNvPr id="27" name="Text 25"/>
+          <p:cNvSpPr/>
+          <p:nvPr/>
+        </p:nvSpPr>
+        <p:spPr>
+          <a:xfrm>
+            <a:off x="8961120" y="3383280"/>
+            <a:ext cx="2651760" cy="640080"/>
+          </a:xfrm>
+          <a:prstGeom prst="rect">
+            <a:avLst/>
+          </a:prstGeom>
+          <a:noFill/>
+          <a:ln/>
+        </p:spPr>
+        <p:txBody>
+          <a:bodyPr wrap="square" rtlCol="0" anchor="ctr"/>
+          <a:lstStyle/>
+          <a:p>
+            <a:pPr indent="0" marL="0">
+              <a:buNone/>
+            </a:pPr>
+            <a:r>
+              <a:rPr lang="en-US" sz="1000" dirty="0">
+                <a:solidFill>
+                  <a:srgbClr val="3730A3"/>
+                </a:solidFill>
+              </a:rPr>
+              <a:t>Alerte pour chaque action importante</a:t>
+            </a:r>
+            <a:endParaRPr lang="en-US" sz="1000" dirty="0"/>
+          </a:p>
+        </p:txBody>
+      </p:sp>
+      <p:sp>
+        <p:nvSpPr>
+          <p:cNvPr id="28" name="Shape 26"/>
+          <p:cNvSpPr/>
+          <p:nvPr/>
+        </p:nvSpPr>
+        <p:spPr>
+          <a:xfrm>
+            <a:off x="274320" y="4572000"/>
+            <a:ext cx="11247120" cy="1463040"/>
+          </a:xfrm>
+          <a:prstGeom prst="roundRect">
+            <a:avLst/>
+          </a:prstGeom>
+          <a:solidFill>
+            <a:srgbClr val="F0FDF4"/>
+          </a:solidFill>
+          <a:ln w="12700">
+            <a:solidFill>
+              <a:srgbClr val="86EFAC"/>
+            </a:solidFill>
+            <a:prstDash val="solid"/>
+          </a:ln>
+        </p:spPr>
+      </p:sp>
+      <p:sp>
+        <p:nvSpPr>
+          <p:cNvPr id="29" name="Text 27"/>
+          <p:cNvSpPr/>
+          <p:nvPr/>
+        </p:nvSpPr>
+        <p:spPr>
+          <a:xfrm>
+            <a:off x="548640" y="4663440"/>
+            <a:ext cx="2286000" cy="365760"/>
+          </a:xfrm>
+          <a:prstGeom prst="rect">
+            <a:avLst/>
+          </a:prstGeom>
+          <a:noFill/>
+          <a:ln/>
+        </p:spPr>
+        <p:txBody>
+          <a:bodyPr wrap="square" rtlCol="0" anchor="ctr"/>
+          <a:lstStyle/>
+          <a:p>
+            <a:pPr indent="0" marL="0">
+              <a:buNone/>
+            </a:pPr>
+            <a:r>
+              <a:rPr lang="en-US" sz="1200" b="1" dirty="0">
+                <a:solidFill>
+                  <a:srgbClr val="15803D"/>
+                </a:solidFill>
+              </a:rPr>
+              <a:t>Multi-tontine :</a:t>
+            </a:r>
+            <a:endParaRPr lang="en-US" sz="1200" dirty="0"/>
+          </a:p>
+        </p:txBody>
+      </p:sp>
+      <p:sp>
+        <p:nvSpPr>
+          <p:cNvPr id="30" name="Text 28"/>
+          <p:cNvSpPr/>
+          <p:nvPr/>
+        </p:nvSpPr>
+        <p:spPr>
+          <a:xfrm>
+            <a:off x="548640" y="5029200"/>
+            <a:ext cx="10972800" cy="731520"/>
+          </a:xfrm>
+          <a:prstGeom prst="rect">
+            <a:avLst/>
+          </a:prstGeom>
+          <a:noFill/>
+          <a:ln/>
+        </p:spPr>
+        <p:txBody>
+          <a:bodyPr wrap="square" rtlCol="0" anchor="ctr"/>
+          <a:lstStyle/>
+          <a:p>
+            <a:pPr indent="0" marL="0">
+              <a:buNone/>
+            </a:pPr>
+            <a:r>
+              <a:rPr lang="en-US" sz="1100" dirty="0">
+                <a:solidFill>
+                  <a:srgbClr val="166534"/>
+                </a:solidFill>
+              </a:rPr>
+              <a:t>Un même compte peut appartenir à plusieurs tontines. L'écran « Mes tontines » à la connexion fixe la tontine courante, et un sélecteur dans l'en-tête permet d'en changer. Cotisations, épargne, prêts, aides, documents et rapports sont cloisonnés sur cette tontine : aucune fuite d'une tontine à l'autre.</a:t>
+            </a:r>
+            <a:endParaRPr lang="en-US" sz="1100" dirty="0"/>
+          </a:p>
+        </p:txBody>
+      </p:sp>
+      <p:sp>
+        <p:nvSpPr>
+          <p:cNvPr id="31" name="Text 29"/>
+          <p:cNvSpPr/>
+          <p:nvPr/>
+        </p:nvSpPr>
+        <p:spPr>
+          <a:xfrm>
+            <a:off x="274320" y="6309360"/>
+            <a:ext cx="10972800" cy="274320"/>
+          </a:xfrm>
+          <a:prstGeom prst="rect">
+            <a:avLst/>
+          </a:prstGeom>
+          <a:noFill/>
+          <a:ln/>
+        </p:spPr>
+        <p:txBody>
+          <a:bodyPr wrap="square" rtlCol="0" anchor="ctr"/>
+          <a:lstStyle/>
+          <a:p>
+            <a:pPr algn="ctr" indent="0" marL="0">
+              <a:buNone/>
+            </a:pPr>
+            <a:r>
+              <a:rPr lang="en-US" sz="800" dirty="0">
+                <a:solidFill>
+                  <a:srgbClr val="94A3B8"/>
+                </a:solidFill>
+              </a:rPr>
+              <a:t>TontinePro v1.1  ·  JumpyTech  ·  © 2026</a:t>
+            </a:r>
+            <a:endParaRPr lang="en-US" sz="800" dirty="0"/>
+          </a:p>
+        </p:txBody>
+      </p:sp>
+      <p:sp>
+        <p:nvSpPr>
+          <p:cNvPr id="32" name="Text 30"/>
+          <p:cNvSpPr/>
+          <p:nvPr/>
+        </p:nvSpPr>
+        <p:spPr>
+          <a:xfrm>
+            <a:off x="11155680" y="6309360"/>
+            <a:ext cx="457200" cy="274320"/>
+          </a:xfrm>
+          <a:prstGeom prst="rect">
+            <a:avLst/>
+          </a:prstGeom>
+          <a:noFill/>
+          <a:ln/>
+        </p:spPr>
+        <p:txBody>
+          <a:bodyPr wrap="square" rtlCol="0" anchor="ctr"/>
+          <a:lstStyle/>
+          <a:p>
+            <a:pPr algn="r" indent="0" marL="0">
+              <a:buNone/>
+            </a:pPr>
+            <a:r>
+              <a:rPr lang="en-US" sz="800" dirty="0">
+                <a:solidFill>
+                  <a:srgbClr val="94A3B8"/>
+                </a:solidFill>
+              </a:rPr>
+              <a:t>7</a:t>
+            </a:r>
+            <a:endParaRPr lang="en-US" sz="800" dirty="0"/>
+          </a:p>
+        </p:txBody>
+      </p:sp>
+    </p:spTree>
+  </p:cSld>
+  <p:clrMapOvr>
+    <a:masterClrMapping/>
+  </p:clrMapOvr>
+</p:sld>
+</file>
+
+<file path=ppt/slides/slide8.xml><?xml version="1.0" encoding="utf-8"?>
+<p:sld xmlns:a="http://schemas.openxmlformats.org/drawingml/2006/main" xmlns:r="http://schemas.openxmlformats.org/officeDocument/2006/relationships" xmlns:p="http://schemas.openxmlformats.org/presentationml/2006/main">
+  <p:cSld name="Slide 8">
     <p:bg>
       <p:bgPr>
         <a:solidFill>
@@ -7053,7 +8587,7 @@
                   <a:srgbClr val="C7D2FE"/>
                 </a:solidFill>
               </a:rPr>
-              <a:t>Poudjoum Leutche Gedeon Rodrigue</a:t>
+              <a:t>Poudjoum Leutcho Gedeon Rodrigue</a:t>
             </a:r>
             <a:endParaRPr lang="en-US" sz="1400" dirty="0"/>
           </a:p>

</xml_diff>